<commit_message>
Hook PPTX: restore hand-tuned build_hook_pptx.py to match hook.html (54pt title, viewport panels, finding-slide subtitle, graduated spine cards) + add disclosures slide with chip cards; reflects current 6-slide structure
</commit_message>
<xml_diff>
--- a/keynote-iwbi-2026/pptx/sections/IWBI2026_Trivedi_00_hook.pptx
+++ b/keynote-iwbi-2026/pptx/sections/IWBI2026_Trivedi_00_hook.pptx
@@ -3880,7 +3880,7 @@
         <p:spPr>
           <a:xfrm>
             <a:off x="0" y="0"/>
-            <a:ext cx="12191695" cy="38100"/>
+            <a:ext cx="5486400" cy="38100"/>
           </a:xfrm>
           <a:prstGeom prst="rect">
             <a:avLst/>
@@ -3923,8 +3923,8 @@
         </p:nvSpPr>
         <p:spPr>
           <a:xfrm>
-            <a:off x="777240" y="2298700"/>
-            <a:ext cx="10607040" cy="346456"/>
+            <a:off x="777240" y="868680"/>
+            <a:ext cx="10607040" cy="365760"/>
           </a:xfrm>
           <a:prstGeom prst="rect">
             <a:avLst/>
@@ -3932,25 +3932,22 @@
           <a:noFill/>
         </p:spPr>
         <p:txBody>
-          <a:bodyPr wrap="square" lIns="25400" rIns="25400" tIns="12700" bIns="12700">
-            <a:noAutofit/>
+          <a:bodyPr wrap="square" anchor="t" lIns="0" rIns="0" tIns="0" bIns="0">
+            <a:spAutoFit/>
           </a:bodyPr>
           <a:lstStyle/>
           <a:p>
             <a:pPr algn="l">
               <a:lnSpc>
-                <a:spcPct val="128000"/>
+                <a:spcPct val="100000"/>
               </a:lnSpc>
-              <a:spcAft>
-                <a:spcPts val="400"/>
-              </a:spcAft>
             </a:pPr>
             <a:r>
-              <a:rPr sz="1400" b="0">
+              <a:rPr sz="1200" b="1" i="0">
                 <a:solidFill>
-                  <a:srgbClr val="9DA9B5"/>
+                  <a:srgbClr val="5FB7C9"/>
                 </a:solidFill>
-                <a:latin typeface="Arial"/>
+                <a:latin typeface="Consolas"/>
               </a:rPr>
               <a:t>International Workshop on Breast Imaging · 2026</a:t>
             </a:r>
@@ -3965,8 +3962,8 @@
         </p:nvSpPr>
         <p:spPr>
           <a:xfrm>
-            <a:off x="777240" y="2645156"/>
-            <a:ext cx="10607040" cy="1586992"/>
+            <a:off x="777240" y="2148840"/>
+            <a:ext cx="10607040" cy="2011680"/>
           </a:xfrm>
           <a:prstGeom prst="rect">
             <a:avLst/>
@@ -3974,21 +3971,18 @@
           <a:noFill/>
         </p:spPr>
         <p:txBody>
-          <a:bodyPr wrap="square" lIns="25400" rIns="25400" tIns="12700" bIns="12700">
-            <a:noAutofit/>
+          <a:bodyPr wrap="square" anchor="t" lIns="0" rIns="0" tIns="0" bIns="0">
+            <a:spAutoFit/>
           </a:bodyPr>
           <a:lstStyle/>
           <a:p>
             <a:pPr algn="l">
               <a:lnSpc>
-                <a:spcPct val="106000"/>
+                <a:spcPct val="98000"/>
               </a:lnSpc>
-              <a:spcAft>
-                <a:spcPts val="400"/>
-              </a:spcAft>
             </a:pPr>
             <a:r>
-              <a:rPr sz="5000" b="0">
+              <a:rPr sz="5400" b="1" i="0">
                 <a:solidFill>
                   <a:srgbClr val="ECEFF3"/>
                 </a:solidFill>
@@ -4000,14 +3994,11 @@
           <a:p>
             <a:pPr algn="l">
               <a:lnSpc>
-                <a:spcPct val="106000"/>
+                <a:spcPct val="98000"/>
               </a:lnSpc>
-              <a:spcAft>
-                <a:spcPts val="400"/>
-              </a:spcAft>
             </a:pPr>
             <a:r>
-              <a:rPr sz="5000" b="0">
+              <a:rPr sz="5400" b="1" i="0">
                 <a:solidFill>
                   <a:srgbClr val="E7AC51"/>
                 </a:solidFill>
@@ -4026,8 +4017,8 @@
         </p:nvSpPr>
         <p:spPr>
           <a:xfrm>
-            <a:off x="777240" y="4232148"/>
-            <a:ext cx="10607040" cy="346456"/>
+            <a:off x="777240" y="4526280"/>
+            <a:ext cx="8686800" cy="822960"/>
           </a:xfrm>
           <a:prstGeom prst="rect">
             <a:avLst/>
@@ -4035,21 +4026,18 @@
           <a:noFill/>
         </p:spPr>
         <p:txBody>
-          <a:bodyPr wrap="square" lIns="25400" rIns="25400" tIns="12700" bIns="12700">
-            <a:noAutofit/>
+          <a:bodyPr wrap="square" anchor="t" lIns="0" rIns="0" tIns="0" bIns="0">
+            <a:spAutoFit/>
           </a:bodyPr>
           <a:lstStyle/>
           <a:p>
             <a:pPr algn="l">
               <a:lnSpc>
-                <a:spcPct val="128000"/>
+                <a:spcPct val="130000"/>
               </a:lnSpc>
-              <a:spcAft>
-                <a:spcPts val="400"/>
-              </a:spcAft>
             </a:pPr>
             <a:r>
-              <a:rPr sz="1400" b="0">
+              <a:rPr sz="2200" b="0" i="0">
                 <a:solidFill>
                   <a:srgbClr val="9DA9B5"/>
                 </a:solidFill>
@@ -4068,8 +4056,8 @@
         </p:nvSpPr>
         <p:spPr>
           <a:xfrm>
-            <a:off x="777240" y="4578604"/>
-            <a:ext cx="10607040" cy="346456"/>
+            <a:off x="777240" y="5577840"/>
+            <a:ext cx="10607040" cy="457200"/>
           </a:xfrm>
           <a:prstGeom prst="rect">
             <a:avLst/>
@@ -4077,36 +4065,33 @@
           <a:noFill/>
         </p:spPr>
         <p:txBody>
-          <a:bodyPr wrap="square" lIns="25400" rIns="25400" tIns="12700" bIns="12700">
-            <a:noAutofit/>
+          <a:bodyPr wrap="square" anchor="t" lIns="0" rIns="0" tIns="0" bIns="0">
+            <a:spAutoFit/>
           </a:bodyPr>
           <a:lstStyle/>
           <a:p>
             <a:pPr algn="l">
               <a:lnSpc>
-                <a:spcPct val="128000"/>
+                <a:spcPct val="100000"/>
               </a:lnSpc>
-              <a:spcAft>
-                <a:spcPts val="400"/>
-              </a:spcAft>
             </a:pPr>
             <a:r>
-              <a:rPr sz="1400" b="1">
+              <a:rPr sz="1400" b="1" i="0">
                 <a:solidFill>
                   <a:srgbClr val="ECEFF3"/>
                 </a:solidFill>
-                <a:latin typeface="Arial"/>
+                <a:latin typeface="Consolas"/>
               </a:rPr>
               <a:t>Hari Trivedi, MD</a:t>
             </a:r>
             <a:r>
-              <a:rPr sz="1400" b="0">
+              <a:rPr sz="1400" b="0" i="0">
                 <a:solidFill>
-                  <a:srgbClr val="9DA9B5"/>
+                  <a:srgbClr val="5C6975"/>
                 </a:solidFill>
-                <a:latin typeface="Arial"/>
+                <a:latin typeface="Consolas"/>
               </a:rPr>
-              <a:t> · Emory University</a:t>
+              <a:t>  ·  Emory University</a:t>
             </a:r>
           </a:p>
         </p:txBody>
@@ -4146,7 +4131,7 @@
         <p:spPr>
           <a:xfrm>
             <a:off x="0" y="0"/>
-            <a:ext cx="12191695" cy="38100"/>
+            <a:ext cx="5486400" cy="38100"/>
           </a:xfrm>
           <a:prstGeom prst="rect">
             <a:avLst/>
@@ -4189,8 +4174,8 @@
         </p:nvSpPr>
         <p:spPr>
           <a:xfrm>
-            <a:off x="777240" y="411480"/>
-            <a:ext cx="8686800" cy="365760"/>
+            <a:off x="777240" y="502920"/>
+            <a:ext cx="8229600" cy="320040"/>
           </a:xfrm>
           <a:prstGeom prst="rect">
             <a:avLst/>
@@ -4198,21 +4183,18 @@
           <a:noFill/>
         </p:spPr>
         <p:txBody>
-          <a:bodyPr wrap="square" lIns="25400" rIns="25400" tIns="12700" bIns="12700">
-            <a:noAutofit/>
+          <a:bodyPr wrap="square" anchor="t" lIns="0" rIns="0" tIns="0" bIns="0">
+            <a:spAutoFit/>
           </a:bodyPr>
           <a:lstStyle/>
           <a:p>
             <a:pPr algn="l">
               <a:lnSpc>
-                <a:spcPct val="128000"/>
+                <a:spcPct val="100000"/>
               </a:lnSpc>
-              <a:spcAft>
-                <a:spcPts val="400"/>
-              </a:spcAft>
             </a:pPr>
             <a:r>
-              <a:rPr sz="1100" b="1">
+              <a:rPr sz="1100" b="1" i="0">
                 <a:solidFill>
                   <a:srgbClr val="E7AC51"/>
                 </a:solidFill>
@@ -4231,8 +4213,8 @@
         </p:nvSpPr>
         <p:spPr>
           <a:xfrm>
-            <a:off x="777240" y="1528064"/>
-            <a:ext cx="10607040" cy="534416"/>
+            <a:off x="777240" y="1078992"/>
+            <a:ext cx="10607040" cy="731520"/>
           </a:xfrm>
           <a:prstGeom prst="rect">
             <a:avLst/>
@@ -4240,21 +4222,18 @@
           <a:noFill/>
         </p:spPr>
         <p:txBody>
-          <a:bodyPr wrap="square" lIns="25400" rIns="25400" tIns="12700" bIns="12700">
-            <a:noAutofit/>
+          <a:bodyPr wrap="square" anchor="t" lIns="0" rIns="0" tIns="0" bIns="0">
+            <a:spAutoFit/>
           </a:bodyPr>
           <a:lstStyle/>
           <a:p>
             <a:pPr algn="l">
               <a:lnSpc>
-                <a:spcPct val="106000"/>
+                <a:spcPct val="100000"/>
               </a:lnSpc>
-              <a:spcAft>
-                <a:spcPts val="400"/>
-              </a:spcAft>
             </a:pPr>
             <a:r>
-              <a:rPr sz="2600" b="0">
+              <a:rPr sz="3800" b="1" i="0">
                 <a:solidFill>
                   <a:srgbClr val="ECEFF3"/>
                 </a:solidFill>
@@ -4273,8 +4252,8 @@
         </p:nvSpPr>
         <p:spPr>
           <a:xfrm>
-            <a:off x="777240" y="2062480"/>
-            <a:ext cx="10607040" cy="222504"/>
+            <a:off x="777240" y="2331720"/>
+            <a:ext cx="10607040" cy="237744"/>
           </a:xfrm>
           <a:prstGeom prst="rect">
             <a:avLst/>
@@ -4282,27 +4261,24 @@
           <a:noFill/>
         </p:spPr>
         <p:txBody>
-          <a:bodyPr wrap="square" lIns="25400" rIns="25400" tIns="12700" bIns="12700">
-            <a:noAutofit/>
+          <a:bodyPr wrap="square" anchor="t" lIns="0" rIns="0" tIns="0" bIns="0">
+            <a:spAutoFit/>
           </a:bodyPr>
           <a:lstStyle/>
           <a:p>
             <a:pPr algn="l">
               <a:lnSpc>
-                <a:spcPct val="120000"/>
+                <a:spcPct val="100000"/>
               </a:lnSpc>
-              <a:spcAft>
-                <a:spcPts val="400"/>
-              </a:spcAft>
             </a:pPr>
             <a:r>
-              <a:rPr sz="1100" b="0">
+              <a:rPr sz="1200" b="1" i="0">
                 <a:solidFill>
                   <a:srgbClr val="E7AC51"/>
                 </a:solidFill>
                 <a:latin typeface="Consolas"/>
               </a:rPr>
-              <a:t>Founder</a:t>
+              <a:t>FOUNDER</a:t>
             </a:r>
           </a:p>
         </p:txBody>
@@ -4315,8 +4291,8 @@
         </p:nvSpPr>
         <p:spPr>
           <a:xfrm>
-            <a:off x="777240" y="2284984"/>
-            <a:ext cx="983996" cy="365760"/>
+            <a:off x="777240" y="2642615"/>
+            <a:ext cx="889000" cy="365760"/>
           </a:xfrm>
           <a:prstGeom prst="roundRect">
             <a:avLst/>
@@ -4326,7 +4302,7 @@
           </a:solidFill>
           <a:ln w="9525">
             <a:solidFill>
-              <a:srgbClr val="2A333E"/>
+              <a:srgbClr val="2A333D"/>
             </a:solidFill>
           </a:ln>
           <a:effectLst/>
@@ -4346,12 +4322,16 @@
           </a:fontRef>
         </p:style>
         <p:txBody>
-          <a:bodyPr rtlCol="0" anchor="ctr" wrap="none" lIns="109728" rIns="73152" tIns="0" bIns="0"/>
-          <a:lstStyle/>
-          <a:p>
-            <a:pPr algn="ctr"/>
-            <a:r>
-              <a:rPr sz="1100">
+          <a:bodyPr rtlCol="0" anchor="ctr" wrap="none" lIns="128016" tIns="0" bIns="0"/>
+          <a:lstStyle/>
+          <a:p>
+            <a:pPr algn="l">
+              <a:lnSpc>
+                <a:spcPct val="100000"/>
+              </a:lnSpc>
+            </a:pPr>
+            <a:r>
+              <a:rPr sz="1100" b="0" i="0">
                 <a:solidFill>
                   <a:srgbClr val="ECEFF3"/>
                 </a:solidFill>
@@ -4370,8 +4350,8 @@
         </p:nvSpPr>
         <p:spPr>
           <a:xfrm>
-            <a:off x="777240" y="2284984"/>
-            <a:ext cx="36576" cy="365760"/>
+            <a:off x="777240" y="2642615"/>
+            <a:ext cx="41148" cy="365760"/>
           </a:xfrm>
           <a:prstGeom prst="rect">
             <a:avLst/>
@@ -4414,8 +4394,8 @@
         </p:nvSpPr>
         <p:spPr>
           <a:xfrm>
-            <a:off x="1852676" y="2284984"/>
-            <a:ext cx="1236408" cy="365760"/>
+            <a:off x="1775968" y="2642615"/>
+            <a:ext cx="1119505" cy="365760"/>
           </a:xfrm>
           <a:prstGeom prst="roundRect">
             <a:avLst/>
@@ -4425,7 +4405,7 @@
           </a:solidFill>
           <a:ln w="9525">
             <a:solidFill>
-              <a:srgbClr val="2A333E"/>
+              <a:srgbClr val="2A333D"/>
             </a:solidFill>
           </a:ln>
           <a:effectLst/>
@@ -4445,12 +4425,16 @@
           </a:fontRef>
         </p:style>
         <p:txBody>
-          <a:bodyPr rtlCol="0" anchor="ctr" wrap="none" lIns="109728" rIns="73152" tIns="0" bIns="0"/>
-          <a:lstStyle/>
-          <a:p>
-            <a:pPr algn="ctr"/>
-            <a:r>
-              <a:rPr sz="1100">
+          <a:bodyPr rtlCol="0" anchor="ctr" wrap="none" lIns="128016" tIns="0" bIns="0"/>
+          <a:lstStyle/>
+          <a:p>
+            <a:pPr algn="l">
+              <a:lnSpc>
+                <a:spcPct val="100000"/>
+              </a:lnSpc>
+            </a:pPr>
+            <a:r>
+              <a:rPr sz="1100" b="0" i="0">
                 <a:solidFill>
                   <a:srgbClr val="ECEFF3"/>
                 </a:solidFill>
@@ -4469,8 +4453,8 @@
         </p:nvSpPr>
         <p:spPr>
           <a:xfrm>
-            <a:off x="1852676" y="2284984"/>
-            <a:ext cx="36576" cy="365760"/>
+            <a:off x="1775968" y="2642615"/>
+            <a:ext cx="41148" cy="365760"/>
           </a:xfrm>
           <a:prstGeom prst="rect">
             <a:avLst/>
@@ -4513,8 +4497,8 @@
         </p:nvSpPr>
         <p:spPr>
           <a:xfrm>
-            <a:off x="777240" y="2778760"/>
-            <a:ext cx="10607040" cy="222504"/>
+            <a:off x="777240" y="3191256"/>
+            <a:ext cx="10607040" cy="237744"/>
           </a:xfrm>
           <a:prstGeom prst="rect">
             <a:avLst/>
@@ -4522,27 +4506,24 @@
           <a:noFill/>
         </p:spPr>
         <p:txBody>
-          <a:bodyPr wrap="square" lIns="25400" rIns="25400" tIns="12700" bIns="12700">
-            <a:noAutofit/>
+          <a:bodyPr wrap="square" anchor="t" lIns="0" rIns="0" tIns="0" bIns="0">
+            <a:spAutoFit/>
           </a:bodyPr>
           <a:lstStyle/>
           <a:p>
             <a:pPr algn="l">
               <a:lnSpc>
-                <a:spcPct val="120000"/>
+                <a:spcPct val="100000"/>
               </a:lnSpc>
-              <a:spcAft>
-                <a:spcPts val="400"/>
-              </a:spcAft>
             </a:pPr>
             <a:r>
-              <a:rPr sz="1100" b="0">
+              <a:rPr sz="1200" b="1" i="0">
                 <a:solidFill>
                   <a:srgbClr val="E7AC51"/>
                 </a:solidFill>
                 <a:latin typeface="Consolas"/>
               </a:rPr>
-              <a:t>Associate CMIO</a:t>
+              <a:t>ASSOCIATE CMIO</a:t>
             </a:r>
           </a:p>
         </p:txBody>
@@ -4555,8 +4536,8 @@
         </p:nvSpPr>
         <p:spPr>
           <a:xfrm>
-            <a:off x="777240" y="3001263"/>
-            <a:ext cx="731583" cy="365760"/>
+            <a:off x="777240" y="3502151"/>
+            <a:ext cx="658495" cy="365760"/>
           </a:xfrm>
           <a:prstGeom prst="roundRect">
             <a:avLst/>
@@ -4566,7 +4547,7 @@
           </a:solidFill>
           <a:ln w="9525">
             <a:solidFill>
-              <a:srgbClr val="2A333E"/>
+              <a:srgbClr val="2A333D"/>
             </a:solidFill>
           </a:ln>
           <a:effectLst/>
@@ -4586,12 +4567,16 @@
           </a:fontRef>
         </p:style>
         <p:txBody>
-          <a:bodyPr rtlCol="0" anchor="ctr" wrap="none" lIns="109728" rIns="73152" tIns="0" bIns="0"/>
-          <a:lstStyle/>
-          <a:p>
-            <a:pPr algn="ctr"/>
-            <a:r>
-              <a:rPr sz="1100">
+          <a:bodyPr rtlCol="0" anchor="ctr" wrap="none" lIns="128016" tIns="0" bIns="0"/>
+          <a:lstStyle/>
+          <a:p>
+            <a:pPr algn="l">
+              <a:lnSpc>
+                <a:spcPct val="100000"/>
+              </a:lnSpc>
+            </a:pPr>
+            <a:r>
+              <a:rPr sz="1100" b="0" i="0">
                 <a:solidFill>
                   <a:srgbClr val="ECEFF3"/>
                 </a:solidFill>
@@ -4610,8 +4595,8 @@
         </p:nvSpPr>
         <p:spPr>
           <a:xfrm>
-            <a:off x="777240" y="3001263"/>
-            <a:ext cx="36576" cy="365760"/>
+            <a:off x="777240" y="3502151"/>
+            <a:ext cx="41148" cy="365760"/>
           </a:xfrm>
           <a:prstGeom prst="rect">
             <a:avLst/>
@@ -4654,8 +4639,8 @@
         </p:nvSpPr>
         <p:spPr>
           <a:xfrm>
-            <a:off x="777240" y="3495039"/>
-            <a:ext cx="10607040" cy="222504"/>
+            <a:off x="777240" y="4050791"/>
+            <a:ext cx="10607040" cy="237744"/>
           </a:xfrm>
           <a:prstGeom prst="rect">
             <a:avLst/>
@@ -4663,27 +4648,24 @@
           <a:noFill/>
         </p:spPr>
         <p:txBody>
-          <a:bodyPr wrap="square" lIns="25400" rIns="25400" tIns="12700" bIns="12700">
-            <a:noAutofit/>
+          <a:bodyPr wrap="square" anchor="t" lIns="0" rIns="0" tIns="0" bIns="0">
+            <a:spAutoFit/>
           </a:bodyPr>
           <a:lstStyle/>
           <a:p>
             <a:pPr algn="l">
               <a:lnSpc>
-                <a:spcPct val="120000"/>
+                <a:spcPct val="100000"/>
               </a:lnSpc>
-              <a:spcAft>
-                <a:spcPts val="400"/>
-              </a:spcAft>
             </a:pPr>
             <a:r>
-              <a:rPr sz="1100" b="0">
+              <a:rPr sz="1200" b="1" i="0">
                 <a:solidFill>
                   <a:srgbClr val="E7AC51"/>
                 </a:solidFill>
                 <a:latin typeface="Consolas"/>
               </a:rPr>
-              <a:t>Advisor</a:t>
+              <a:t>ADVISOR</a:t>
             </a:r>
           </a:p>
         </p:txBody>
@@ -4696,8 +4678,8 @@
         </p:nvSpPr>
         <p:spPr>
           <a:xfrm>
-            <a:off x="777240" y="3717543"/>
-            <a:ext cx="1068133" cy="365760"/>
+            <a:off x="777240" y="4361688"/>
+            <a:ext cx="965835" cy="365760"/>
           </a:xfrm>
           <a:prstGeom prst="roundRect">
             <a:avLst/>
@@ -4707,7 +4689,7 @@
           </a:solidFill>
           <a:ln w="9525">
             <a:solidFill>
-              <a:srgbClr val="2A333E"/>
+              <a:srgbClr val="2A333D"/>
             </a:solidFill>
           </a:ln>
           <a:effectLst/>
@@ -4727,12 +4709,16 @@
           </a:fontRef>
         </p:style>
         <p:txBody>
-          <a:bodyPr rtlCol="0" anchor="ctr" wrap="none" lIns="109728" rIns="73152" tIns="0" bIns="0"/>
-          <a:lstStyle/>
-          <a:p>
-            <a:pPr algn="ctr"/>
-            <a:r>
-              <a:rPr sz="1100">
+          <a:bodyPr rtlCol="0" anchor="ctr" wrap="none" lIns="128016" tIns="0" bIns="0"/>
+          <a:lstStyle/>
+          <a:p>
+            <a:pPr algn="l">
+              <a:lnSpc>
+                <a:spcPct val="100000"/>
+              </a:lnSpc>
+            </a:pPr>
+            <a:r>
+              <a:rPr sz="1100" b="0" i="0">
                 <a:solidFill>
                   <a:srgbClr val="ECEFF3"/>
                 </a:solidFill>
@@ -4751,8 +4737,8 @@
         </p:nvSpPr>
         <p:spPr>
           <a:xfrm>
-            <a:off x="777240" y="3717543"/>
-            <a:ext cx="36576" cy="365760"/>
+            <a:off x="777240" y="4361688"/>
+            <a:ext cx="41148" cy="365760"/>
           </a:xfrm>
           <a:prstGeom prst="rect">
             <a:avLst/>
@@ -4795,8 +4781,8 @@
         </p:nvSpPr>
         <p:spPr>
           <a:xfrm>
-            <a:off x="1936813" y="3717543"/>
-            <a:ext cx="1741233" cy="365760"/>
+            <a:off x="1852803" y="4361688"/>
+            <a:ext cx="1580515" cy="365760"/>
           </a:xfrm>
           <a:prstGeom prst="roundRect">
             <a:avLst/>
@@ -4806,7 +4792,7 @@
           </a:solidFill>
           <a:ln w="9525">
             <a:solidFill>
-              <a:srgbClr val="2A333E"/>
+              <a:srgbClr val="2A333D"/>
             </a:solidFill>
           </a:ln>
           <a:effectLst/>
@@ -4826,12 +4812,16 @@
           </a:fontRef>
         </p:style>
         <p:txBody>
-          <a:bodyPr rtlCol="0" anchor="ctr" wrap="none" lIns="109728" rIns="73152" tIns="0" bIns="0"/>
-          <a:lstStyle/>
-          <a:p>
-            <a:pPr algn="ctr"/>
-            <a:r>
-              <a:rPr sz="1100">
+          <a:bodyPr rtlCol="0" anchor="ctr" wrap="none" lIns="128016" tIns="0" bIns="0"/>
+          <a:lstStyle/>
+          <a:p>
+            <a:pPr algn="l">
+              <a:lnSpc>
+                <a:spcPct val="100000"/>
+              </a:lnSpc>
+            </a:pPr>
+            <a:r>
+              <a:rPr sz="1100" b="0" i="0">
                 <a:solidFill>
                   <a:srgbClr val="ECEFF3"/>
                 </a:solidFill>
@@ -4850,8 +4840,8 @@
         </p:nvSpPr>
         <p:spPr>
           <a:xfrm>
-            <a:off x="1936813" y="3717543"/>
-            <a:ext cx="36576" cy="365760"/>
+            <a:off x="1852803" y="4361688"/>
+            <a:ext cx="41148" cy="365760"/>
           </a:xfrm>
           <a:prstGeom prst="rect">
             <a:avLst/>
@@ -4894,8 +4884,8 @@
         </p:nvSpPr>
         <p:spPr>
           <a:xfrm>
-            <a:off x="3769487" y="3717543"/>
-            <a:ext cx="1488821" cy="365760"/>
+            <a:off x="3543046" y="4361688"/>
+            <a:ext cx="1350010" cy="365760"/>
           </a:xfrm>
           <a:prstGeom prst="roundRect">
             <a:avLst/>
@@ -4905,7 +4895,7 @@
           </a:solidFill>
           <a:ln w="9525">
             <a:solidFill>
-              <a:srgbClr val="2A333E"/>
+              <a:srgbClr val="2A333D"/>
             </a:solidFill>
           </a:ln>
           <a:effectLst/>
@@ -4925,12 +4915,16 @@
           </a:fontRef>
         </p:style>
         <p:txBody>
-          <a:bodyPr rtlCol="0" anchor="ctr" wrap="none" lIns="109728" rIns="73152" tIns="0" bIns="0"/>
-          <a:lstStyle/>
-          <a:p>
-            <a:pPr algn="ctr"/>
-            <a:r>
-              <a:rPr sz="1100">
+          <a:bodyPr rtlCol="0" anchor="ctr" wrap="none" lIns="128016" tIns="0" bIns="0"/>
+          <a:lstStyle/>
+          <a:p>
+            <a:pPr algn="l">
+              <a:lnSpc>
+                <a:spcPct val="100000"/>
+              </a:lnSpc>
+            </a:pPr>
+            <a:r>
+              <a:rPr sz="1100" b="0" i="0">
                 <a:solidFill>
                   <a:srgbClr val="ECEFF3"/>
                 </a:solidFill>
@@ -4949,8 +4943,8 @@
         </p:nvSpPr>
         <p:spPr>
           <a:xfrm>
-            <a:off x="3769487" y="3717543"/>
-            <a:ext cx="36576" cy="365760"/>
+            <a:off x="3543046" y="4361688"/>
+            <a:ext cx="41148" cy="365760"/>
           </a:xfrm>
           <a:prstGeom prst="rect">
             <a:avLst/>
@@ -4993,8 +4987,8 @@
         </p:nvSpPr>
         <p:spPr>
           <a:xfrm>
-            <a:off x="5349748" y="3717543"/>
-            <a:ext cx="1572958" cy="365760"/>
+            <a:off x="5002784" y="4361688"/>
+            <a:ext cx="1426845" cy="365760"/>
           </a:xfrm>
           <a:prstGeom prst="roundRect">
             <a:avLst/>
@@ -5004,7 +4998,7 @@
           </a:solidFill>
           <a:ln w="9525">
             <a:solidFill>
-              <a:srgbClr val="2A333E"/>
+              <a:srgbClr val="2A333D"/>
             </a:solidFill>
           </a:ln>
           <a:effectLst/>
@@ -5024,12 +5018,16 @@
           </a:fontRef>
         </p:style>
         <p:txBody>
-          <a:bodyPr rtlCol="0" anchor="ctr" wrap="none" lIns="109728" rIns="73152" tIns="0" bIns="0"/>
-          <a:lstStyle/>
-          <a:p>
-            <a:pPr algn="ctr"/>
-            <a:r>
-              <a:rPr sz="1100">
+          <a:bodyPr rtlCol="0" anchor="ctr" wrap="none" lIns="128016" tIns="0" bIns="0"/>
+          <a:lstStyle/>
+          <a:p>
+            <a:pPr algn="l">
+              <a:lnSpc>
+                <a:spcPct val="100000"/>
+              </a:lnSpc>
+            </a:pPr>
+            <a:r>
+              <a:rPr sz="1100" b="0" i="0">
                 <a:solidFill>
                   <a:srgbClr val="ECEFF3"/>
                 </a:solidFill>
@@ -5048,8 +5046,8 @@
         </p:nvSpPr>
         <p:spPr>
           <a:xfrm>
-            <a:off x="5349748" y="3717543"/>
-            <a:ext cx="36576" cy="365760"/>
+            <a:off x="5002784" y="4361688"/>
+            <a:ext cx="41148" cy="365760"/>
           </a:xfrm>
           <a:prstGeom prst="rect">
             <a:avLst/>
@@ -5092,8 +5090,8 @@
         </p:nvSpPr>
         <p:spPr>
           <a:xfrm>
-            <a:off x="7014146" y="3717543"/>
-            <a:ext cx="1236408" cy="365760"/>
+            <a:off x="6539357" y="4361688"/>
+            <a:ext cx="1119505" cy="365760"/>
           </a:xfrm>
           <a:prstGeom prst="roundRect">
             <a:avLst/>
@@ -5103,7 +5101,7 @@
           </a:solidFill>
           <a:ln w="9525">
             <a:solidFill>
-              <a:srgbClr val="2A333E"/>
+              <a:srgbClr val="2A333D"/>
             </a:solidFill>
           </a:ln>
           <a:effectLst/>
@@ -5123,12 +5121,16 @@
           </a:fontRef>
         </p:style>
         <p:txBody>
-          <a:bodyPr rtlCol="0" anchor="ctr" wrap="none" lIns="109728" rIns="73152" tIns="0" bIns="0"/>
-          <a:lstStyle/>
-          <a:p>
-            <a:pPr algn="ctr"/>
-            <a:r>
-              <a:rPr sz="1100">
+          <a:bodyPr rtlCol="0" anchor="ctr" wrap="none" lIns="128016" tIns="0" bIns="0"/>
+          <a:lstStyle/>
+          <a:p>
+            <a:pPr algn="l">
+              <a:lnSpc>
+                <a:spcPct val="100000"/>
+              </a:lnSpc>
+            </a:pPr>
+            <a:r>
+              <a:rPr sz="1100" b="0" i="0">
                 <a:solidFill>
                   <a:srgbClr val="ECEFF3"/>
                 </a:solidFill>
@@ -5147,8 +5149,8 @@
         </p:nvSpPr>
         <p:spPr>
           <a:xfrm>
-            <a:off x="7014146" y="3717543"/>
-            <a:ext cx="36576" cy="365760"/>
+            <a:off x="6539357" y="4361688"/>
+            <a:ext cx="41148" cy="365760"/>
           </a:xfrm>
           <a:prstGeom prst="rect">
             <a:avLst/>
@@ -5191,8 +5193,8 @@
         </p:nvSpPr>
         <p:spPr>
           <a:xfrm>
-            <a:off x="8341995" y="3717543"/>
-            <a:ext cx="1993645" cy="365760"/>
+            <a:off x="7768590" y="4361688"/>
+            <a:ext cx="1811020" cy="365760"/>
           </a:xfrm>
           <a:prstGeom prst="roundRect">
             <a:avLst/>
@@ -5202,7 +5204,7 @@
           </a:solidFill>
           <a:ln w="9525">
             <a:solidFill>
-              <a:srgbClr val="2A333E"/>
+              <a:srgbClr val="2A333D"/>
             </a:solidFill>
           </a:ln>
           <a:effectLst/>
@@ -5222,12 +5224,16 @@
           </a:fontRef>
         </p:style>
         <p:txBody>
-          <a:bodyPr rtlCol="0" anchor="ctr" wrap="none" lIns="109728" rIns="73152" tIns="0" bIns="0"/>
-          <a:lstStyle/>
-          <a:p>
-            <a:pPr algn="ctr"/>
-            <a:r>
-              <a:rPr sz="1100">
+          <a:bodyPr rtlCol="0" anchor="ctr" wrap="none" lIns="128016" tIns="0" bIns="0"/>
+          <a:lstStyle/>
+          <a:p>
+            <a:pPr algn="l">
+              <a:lnSpc>
+                <a:spcPct val="100000"/>
+              </a:lnSpc>
+            </a:pPr>
+            <a:r>
+              <a:rPr sz="1100" b="0" i="0">
                 <a:solidFill>
                   <a:srgbClr val="ECEFF3"/>
                 </a:solidFill>
@@ -5246,8 +5252,8 @@
         </p:nvSpPr>
         <p:spPr>
           <a:xfrm>
-            <a:off x="8341995" y="3717543"/>
-            <a:ext cx="36576" cy="365760"/>
+            <a:off x="7768590" y="4361688"/>
+            <a:ext cx="41148" cy="365760"/>
           </a:xfrm>
           <a:prstGeom prst="rect">
             <a:avLst/>
@@ -5290,8 +5296,8 @@
         </p:nvSpPr>
         <p:spPr>
           <a:xfrm>
-            <a:off x="777240" y="4156456"/>
-            <a:ext cx="1825371" cy="365760"/>
+            <a:off x="9689338" y="4361688"/>
+            <a:ext cx="1657350" cy="365760"/>
           </a:xfrm>
           <a:prstGeom prst="roundRect">
             <a:avLst/>
@@ -5301,7 +5307,7 @@
           </a:solidFill>
           <a:ln w="9525">
             <a:solidFill>
-              <a:srgbClr val="2A333E"/>
+              <a:srgbClr val="2A333D"/>
             </a:solidFill>
           </a:ln>
           <a:effectLst/>
@@ -5321,12 +5327,16 @@
           </a:fontRef>
         </p:style>
         <p:txBody>
-          <a:bodyPr rtlCol="0" anchor="ctr" wrap="none" lIns="109728" rIns="73152" tIns="0" bIns="0"/>
-          <a:lstStyle/>
-          <a:p>
-            <a:pPr algn="ctr"/>
-            <a:r>
-              <a:rPr sz="1100">
+          <a:bodyPr rtlCol="0" anchor="ctr" wrap="none" lIns="128016" tIns="0" bIns="0"/>
+          <a:lstStyle/>
+          <a:p>
+            <a:pPr algn="l">
+              <a:lnSpc>
+                <a:spcPct val="100000"/>
+              </a:lnSpc>
+            </a:pPr>
+            <a:r>
+              <a:rPr sz="1100" b="0" i="0">
                 <a:solidFill>
                   <a:srgbClr val="ECEFF3"/>
                 </a:solidFill>
@@ -5345,8 +5355,8 @@
         </p:nvSpPr>
         <p:spPr>
           <a:xfrm>
-            <a:off x="777240" y="4156456"/>
-            <a:ext cx="36576" cy="365760"/>
+            <a:off x="9689338" y="4361688"/>
+            <a:ext cx="41148" cy="365760"/>
           </a:xfrm>
           <a:prstGeom prst="rect">
             <a:avLst/>
@@ -5389,8 +5399,8 @@
         </p:nvSpPr>
         <p:spPr>
           <a:xfrm>
-            <a:off x="777240" y="4650232"/>
-            <a:ext cx="10607040" cy="222504"/>
+            <a:off x="777240" y="4910327"/>
+            <a:ext cx="10607040" cy="237744"/>
           </a:xfrm>
           <a:prstGeom prst="rect">
             <a:avLst/>
@@ -5398,27 +5408,24 @@
           <a:noFill/>
         </p:spPr>
         <p:txBody>
-          <a:bodyPr wrap="square" lIns="25400" rIns="25400" tIns="12700" bIns="12700">
-            <a:noAutofit/>
+          <a:bodyPr wrap="square" anchor="t" lIns="0" rIns="0" tIns="0" bIns="0">
+            <a:spAutoFit/>
           </a:bodyPr>
           <a:lstStyle/>
           <a:p>
             <a:pPr algn="l">
               <a:lnSpc>
-                <a:spcPct val="120000"/>
+                <a:spcPct val="100000"/>
               </a:lnSpc>
-              <a:spcAft>
-                <a:spcPts val="400"/>
-              </a:spcAft>
             </a:pPr>
             <a:r>
-              <a:rPr sz="1100" b="0">
+              <a:rPr sz="1200" b="1" i="0">
                 <a:solidFill>
                   <a:srgbClr val="E7AC51"/>
                 </a:solidFill>
                 <a:latin typeface="Consolas"/>
               </a:rPr>
-              <a:t>Industry / Foundation Support</a:t>
+              <a:t>INDUSTRY / FOUNDATION SUPPORT</a:t>
             </a:r>
           </a:p>
         </p:txBody>
@@ -5431,8 +5438,8 @@
         </p:nvSpPr>
         <p:spPr>
           <a:xfrm>
-            <a:off x="777240" y="4872736"/>
-            <a:ext cx="1068133" cy="365760"/>
+            <a:off x="777240" y="5221223"/>
+            <a:ext cx="965835" cy="365760"/>
           </a:xfrm>
           <a:prstGeom prst="roundRect">
             <a:avLst/>
@@ -5442,7 +5449,7 @@
           </a:solidFill>
           <a:ln w="9525">
             <a:solidFill>
-              <a:srgbClr val="2A333E"/>
+              <a:srgbClr val="2A333D"/>
             </a:solidFill>
           </a:ln>
           <a:effectLst/>
@@ -5462,12 +5469,16 @@
           </a:fontRef>
         </p:style>
         <p:txBody>
-          <a:bodyPr rtlCol="0" anchor="ctr" wrap="none" lIns="109728" rIns="73152" tIns="0" bIns="0"/>
-          <a:lstStyle/>
-          <a:p>
-            <a:pPr algn="ctr"/>
-            <a:r>
-              <a:rPr sz="1100">
+          <a:bodyPr rtlCol="0" anchor="ctr" wrap="none" lIns="128016" tIns="0" bIns="0"/>
+          <a:lstStyle/>
+          <a:p>
+            <a:pPr algn="l">
+              <a:lnSpc>
+                <a:spcPct val="100000"/>
+              </a:lnSpc>
+            </a:pPr>
+            <a:r>
+              <a:rPr sz="1100" b="0" i="0">
                 <a:solidFill>
                   <a:srgbClr val="ECEFF3"/>
                 </a:solidFill>
@@ -5486,8 +5497,8 @@
         </p:nvSpPr>
         <p:spPr>
           <a:xfrm>
-            <a:off x="777240" y="4872736"/>
-            <a:ext cx="36576" cy="365760"/>
+            <a:off x="777240" y="5221223"/>
+            <a:ext cx="41148" cy="365760"/>
           </a:xfrm>
           <a:prstGeom prst="rect">
             <a:avLst/>
@@ -5530,8 +5541,8 @@
         </p:nvSpPr>
         <p:spPr>
           <a:xfrm>
-            <a:off x="1936813" y="4872736"/>
-            <a:ext cx="731583" cy="365760"/>
+            <a:off x="1852803" y="5221223"/>
+            <a:ext cx="658495" cy="365760"/>
           </a:xfrm>
           <a:prstGeom prst="roundRect">
             <a:avLst/>
@@ -5541,7 +5552,7 @@
           </a:solidFill>
           <a:ln w="9525">
             <a:solidFill>
-              <a:srgbClr val="2A333E"/>
+              <a:srgbClr val="2A333D"/>
             </a:solidFill>
           </a:ln>
           <a:effectLst/>
@@ -5561,12 +5572,16 @@
           </a:fontRef>
         </p:style>
         <p:txBody>
-          <a:bodyPr rtlCol="0" anchor="ctr" wrap="none" lIns="109728" rIns="73152" tIns="0" bIns="0"/>
-          <a:lstStyle/>
-          <a:p>
-            <a:pPr algn="ctr"/>
-            <a:r>
-              <a:rPr sz="1100">
+          <a:bodyPr rtlCol="0" anchor="ctr" wrap="none" lIns="128016" tIns="0" bIns="0"/>
+          <a:lstStyle/>
+          <a:p>
+            <a:pPr algn="l">
+              <a:lnSpc>
+                <a:spcPct val="100000"/>
+              </a:lnSpc>
+            </a:pPr>
+            <a:r>
+              <a:rPr sz="1100" b="0" i="0">
                 <a:solidFill>
                   <a:srgbClr val="ECEFF3"/>
                 </a:solidFill>
@@ -5585,8 +5600,8 @@
         </p:nvSpPr>
         <p:spPr>
           <a:xfrm>
-            <a:off x="1936813" y="4872736"/>
-            <a:ext cx="36576" cy="365760"/>
+            <a:off x="1852803" y="5221223"/>
+            <a:ext cx="41148" cy="365760"/>
           </a:xfrm>
           <a:prstGeom prst="rect">
             <a:avLst/>
@@ -5629,8 +5644,8 @@
         </p:nvSpPr>
         <p:spPr>
           <a:xfrm>
-            <a:off x="2759837" y="4872736"/>
-            <a:ext cx="983996" cy="365760"/>
+            <a:off x="2621026" y="5221223"/>
+            <a:ext cx="889000" cy="365760"/>
           </a:xfrm>
           <a:prstGeom prst="roundRect">
             <a:avLst/>
@@ -5640,7 +5655,7 @@
           </a:solidFill>
           <a:ln w="9525">
             <a:solidFill>
-              <a:srgbClr val="2A333E"/>
+              <a:srgbClr val="2A333D"/>
             </a:solidFill>
           </a:ln>
           <a:effectLst/>
@@ -5660,12 +5675,16 @@
           </a:fontRef>
         </p:style>
         <p:txBody>
-          <a:bodyPr rtlCol="0" anchor="ctr" wrap="none" lIns="109728" rIns="73152" tIns="0" bIns="0"/>
-          <a:lstStyle/>
-          <a:p>
-            <a:pPr algn="ctr"/>
-            <a:r>
-              <a:rPr sz="1100">
+          <a:bodyPr rtlCol="0" anchor="ctr" wrap="none" lIns="128016" tIns="0" bIns="0"/>
+          <a:lstStyle/>
+          <a:p>
+            <a:pPr algn="l">
+              <a:lnSpc>
+                <a:spcPct val="100000"/>
+              </a:lnSpc>
+            </a:pPr>
+            <a:r>
+              <a:rPr sz="1100" b="0" i="0">
                 <a:solidFill>
                   <a:srgbClr val="ECEFF3"/>
                 </a:solidFill>
@@ -5684,8 +5703,8 @@
         </p:nvSpPr>
         <p:spPr>
           <a:xfrm>
-            <a:off x="2759837" y="4872736"/>
-            <a:ext cx="36576" cy="365760"/>
+            <a:off x="2621026" y="5221223"/>
+            <a:ext cx="41148" cy="365760"/>
           </a:xfrm>
           <a:prstGeom prst="rect">
             <a:avLst/>
@@ -5728,8 +5747,8 @@
         </p:nvSpPr>
         <p:spPr>
           <a:xfrm>
-            <a:off x="3835273" y="4872736"/>
-            <a:ext cx="731583" cy="365760"/>
+            <a:off x="3619754" y="5221223"/>
+            <a:ext cx="658495" cy="365760"/>
           </a:xfrm>
           <a:prstGeom prst="roundRect">
             <a:avLst/>
@@ -5739,7 +5758,7 @@
           </a:solidFill>
           <a:ln w="9525">
             <a:solidFill>
-              <a:srgbClr val="2A333E"/>
+              <a:srgbClr val="2A333D"/>
             </a:solidFill>
           </a:ln>
           <a:effectLst/>
@@ -5759,12 +5778,16 @@
           </a:fontRef>
         </p:style>
         <p:txBody>
-          <a:bodyPr rtlCol="0" anchor="ctr" wrap="none" lIns="109728" rIns="73152" tIns="0" bIns="0"/>
-          <a:lstStyle/>
-          <a:p>
-            <a:pPr algn="ctr"/>
-            <a:r>
-              <a:rPr sz="1100">
+          <a:bodyPr rtlCol="0" anchor="ctr" wrap="none" lIns="128016" tIns="0" bIns="0"/>
+          <a:lstStyle/>
+          <a:p>
+            <a:pPr algn="l">
+              <a:lnSpc>
+                <a:spcPct val="100000"/>
+              </a:lnSpc>
+            </a:pPr>
+            <a:r>
+              <a:rPr sz="1100" b="0" i="0">
                 <a:solidFill>
                   <a:srgbClr val="ECEFF3"/>
                 </a:solidFill>
@@ -5783,8 +5806,8 @@
         </p:nvSpPr>
         <p:spPr>
           <a:xfrm>
-            <a:off x="3835273" y="4872736"/>
-            <a:ext cx="36576" cy="365760"/>
+            <a:off x="3619754" y="5221223"/>
+            <a:ext cx="41148" cy="365760"/>
           </a:xfrm>
           <a:prstGeom prst="rect">
             <a:avLst/>
@@ -5827,8 +5850,8 @@
         </p:nvSpPr>
         <p:spPr>
           <a:xfrm>
-            <a:off x="4658296" y="4872736"/>
-            <a:ext cx="1657096" cy="365760"/>
+            <a:off x="4387977" y="5221223"/>
+            <a:ext cx="1503680" cy="365760"/>
           </a:xfrm>
           <a:prstGeom prst="roundRect">
             <a:avLst/>
@@ -5838,7 +5861,7 @@
           </a:solidFill>
           <a:ln w="9525">
             <a:solidFill>
-              <a:srgbClr val="2A333E"/>
+              <a:srgbClr val="2A333D"/>
             </a:solidFill>
           </a:ln>
           <a:effectLst/>
@@ -5858,12 +5881,16 @@
           </a:fontRef>
         </p:style>
         <p:txBody>
-          <a:bodyPr rtlCol="0" anchor="ctr" wrap="none" lIns="109728" rIns="73152" tIns="0" bIns="0"/>
-          <a:lstStyle/>
-          <a:p>
-            <a:pPr algn="ctr"/>
-            <a:r>
-              <a:rPr sz="1100">
+          <a:bodyPr rtlCol="0" anchor="ctr" wrap="none" lIns="128016" tIns="0" bIns="0"/>
+          <a:lstStyle/>
+          <a:p>
+            <a:pPr algn="l">
+              <a:lnSpc>
+                <a:spcPct val="100000"/>
+              </a:lnSpc>
+            </a:pPr>
+            <a:r>
+              <a:rPr sz="1100" b="0" i="0">
                 <a:solidFill>
                   <a:srgbClr val="ECEFF3"/>
                 </a:solidFill>
@@ -5882,8 +5909,8 @@
         </p:nvSpPr>
         <p:spPr>
           <a:xfrm>
-            <a:off x="4658296" y="4872736"/>
-            <a:ext cx="36576" cy="365760"/>
+            <a:off x="4387977" y="5221223"/>
+            <a:ext cx="41148" cy="365760"/>
           </a:xfrm>
           <a:prstGeom prst="rect">
             <a:avLst/>
@@ -5926,8 +5953,8 @@
         </p:nvSpPr>
         <p:spPr>
           <a:xfrm>
-            <a:off x="6406832" y="4872736"/>
-            <a:ext cx="1572958" cy="365760"/>
+            <a:off x="6001385" y="5221223"/>
+            <a:ext cx="1426845" cy="365760"/>
           </a:xfrm>
           <a:prstGeom prst="roundRect">
             <a:avLst/>
@@ -5937,7 +5964,7 @@
           </a:solidFill>
           <a:ln w="9525">
             <a:solidFill>
-              <a:srgbClr val="2A333E"/>
+              <a:srgbClr val="2A333D"/>
             </a:solidFill>
           </a:ln>
           <a:effectLst/>
@@ -5957,12 +5984,16 @@
           </a:fontRef>
         </p:style>
         <p:txBody>
-          <a:bodyPr rtlCol="0" anchor="ctr" wrap="none" lIns="109728" rIns="73152" tIns="0" bIns="0"/>
-          <a:lstStyle/>
-          <a:p>
-            <a:pPr algn="ctr"/>
-            <a:r>
-              <a:rPr sz="1100">
+          <a:bodyPr rtlCol="0" anchor="ctr" wrap="none" lIns="128016" tIns="0" bIns="0"/>
+          <a:lstStyle/>
+          <a:p>
+            <a:pPr algn="l">
+              <a:lnSpc>
+                <a:spcPct val="100000"/>
+              </a:lnSpc>
+            </a:pPr>
+            <a:r>
+              <a:rPr sz="1100" b="0" i="0">
                 <a:solidFill>
                   <a:srgbClr val="ECEFF3"/>
                 </a:solidFill>
@@ -5981,8 +6012,8 @@
         </p:nvSpPr>
         <p:spPr>
           <a:xfrm>
-            <a:off x="6406832" y="4872736"/>
-            <a:ext cx="36576" cy="365760"/>
+            <a:off x="6001385" y="5221223"/>
+            <a:ext cx="41148" cy="365760"/>
           </a:xfrm>
           <a:prstGeom prst="rect">
             <a:avLst/>
@@ -6025,8 +6056,8 @@
         </p:nvSpPr>
         <p:spPr>
           <a:xfrm>
-            <a:off x="8071231" y="4872736"/>
-            <a:ext cx="479171" cy="365760"/>
+            <a:off x="7537958" y="5221223"/>
+            <a:ext cx="427990" cy="365760"/>
           </a:xfrm>
           <a:prstGeom prst="roundRect">
             <a:avLst/>
@@ -6036,7 +6067,7 @@
           </a:solidFill>
           <a:ln w="9525">
             <a:solidFill>
-              <a:srgbClr val="2A333E"/>
+              <a:srgbClr val="2A333D"/>
             </a:solidFill>
           </a:ln>
           <a:effectLst/>
@@ -6056,12 +6087,16 @@
           </a:fontRef>
         </p:style>
         <p:txBody>
-          <a:bodyPr rtlCol="0" anchor="ctr" wrap="none" lIns="109728" rIns="73152" tIns="0" bIns="0"/>
-          <a:lstStyle/>
-          <a:p>
-            <a:pPr algn="ctr"/>
-            <a:r>
-              <a:rPr sz="1100">
+          <a:bodyPr rtlCol="0" anchor="ctr" wrap="none" lIns="128016" tIns="0" bIns="0"/>
+          <a:lstStyle/>
+          <a:p>
+            <a:pPr algn="l">
+              <a:lnSpc>
+                <a:spcPct val="100000"/>
+              </a:lnSpc>
+            </a:pPr>
+            <a:r>
+              <a:rPr sz="1100" b="0" i="0">
                 <a:solidFill>
                   <a:srgbClr val="ECEFF3"/>
                 </a:solidFill>
@@ -6080,8 +6115,8 @@
         </p:nvSpPr>
         <p:spPr>
           <a:xfrm>
-            <a:off x="8071231" y="4872736"/>
-            <a:ext cx="36576" cy="365760"/>
+            <a:off x="7537958" y="5221223"/>
+            <a:ext cx="41148" cy="365760"/>
           </a:xfrm>
           <a:prstGeom prst="rect">
             <a:avLst/>
@@ -6124,8 +6159,8 @@
         </p:nvSpPr>
         <p:spPr>
           <a:xfrm>
-            <a:off x="8641842" y="4872736"/>
-            <a:ext cx="647446" cy="365760"/>
+            <a:off x="8075676" y="5221223"/>
+            <a:ext cx="581660" cy="365760"/>
           </a:xfrm>
           <a:prstGeom prst="roundRect">
             <a:avLst/>
@@ -6135,7 +6170,7 @@
           </a:solidFill>
           <a:ln w="9525">
             <a:solidFill>
-              <a:srgbClr val="2A333E"/>
+              <a:srgbClr val="2A333D"/>
             </a:solidFill>
           </a:ln>
           <a:effectLst/>
@@ -6155,12 +6190,16 @@
           </a:fontRef>
         </p:style>
         <p:txBody>
-          <a:bodyPr rtlCol="0" anchor="ctr" wrap="none" lIns="109728" rIns="73152" tIns="0" bIns="0"/>
-          <a:lstStyle/>
-          <a:p>
-            <a:pPr algn="ctr"/>
-            <a:r>
-              <a:rPr sz="1100">
+          <a:bodyPr rtlCol="0" anchor="ctr" wrap="none" lIns="128016" tIns="0" bIns="0"/>
+          <a:lstStyle/>
+          <a:p>
+            <a:pPr algn="l">
+              <a:lnSpc>
+                <a:spcPct val="100000"/>
+              </a:lnSpc>
+            </a:pPr>
+            <a:r>
+              <a:rPr sz="1100" b="0" i="0">
                 <a:solidFill>
                   <a:srgbClr val="ECEFF3"/>
                 </a:solidFill>
@@ -6179,8 +6218,8 @@
         </p:nvSpPr>
         <p:spPr>
           <a:xfrm>
-            <a:off x="8641842" y="4872736"/>
-            <a:ext cx="36576" cy="365760"/>
+            <a:off x="8075676" y="5221223"/>
+            <a:ext cx="41148" cy="365760"/>
           </a:xfrm>
           <a:prstGeom prst="rect">
             <a:avLst/>
@@ -6223,8 +6262,8 @@
         </p:nvSpPr>
         <p:spPr>
           <a:xfrm>
-            <a:off x="9380728" y="4872736"/>
-            <a:ext cx="983996" cy="365760"/>
+            <a:off x="8767064" y="5221223"/>
+            <a:ext cx="889000" cy="365760"/>
           </a:xfrm>
           <a:prstGeom prst="roundRect">
             <a:avLst/>
@@ -6234,7 +6273,7 @@
           </a:solidFill>
           <a:ln w="9525">
             <a:solidFill>
-              <a:srgbClr val="2A333E"/>
+              <a:srgbClr val="2A333D"/>
             </a:solidFill>
           </a:ln>
           <a:effectLst/>
@@ -6254,12 +6293,16 @@
           </a:fontRef>
         </p:style>
         <p:txBody>
-          <a:bodyPr rtlCol="0" anchor="ctr" wrap="none" lIns="109728" rIns="73152" tIns="0" bIns="0"/>
-          <a:lstStyle/>
-          <a:p>
-            <a:pPr algn="ctr"/>
-            <a:r>
-              <a:rPr sz="1100">
+          <a:bodyPr rtlCol="0" anchor="ctr" wrap="none" lIns="128016" tIns="0" bIns="0"/>
+          <a:lstStyle/>
+          <a:p>
+            <a:pPr algn="l">
+              <a:lnSpc>
+                <a:spcPct val="100000"/>
+              </a:lnSpc>
+            </a:pPr>
+            <a:r>
+              <a:rPr sz="1100" b="0" i="0">
                 <a:solidFill>
                   <a:srgbClr val="ECEFF3"/>
                 </a:solidFill>
@@ -6278,8 +6321,8 @@
         </p:nvSpPr>
         <p:spPr>
           <a:xfrm>
-            <a:off x="9380728" y="4872736"/>
-            <a:ext cx="36576" cy="365760"/>
+            <a:off x="8767064" y="5221223"/>
+            <a:ext cx="41148" cy="365760"/>
           </a:xfrm>
           <a:prstGeom prst="rect">
             <a:avLst/>
@@ -6322,8 +6365,8 @@
         </p:nvSpPr>
         <p:spPr>
           <a:xfrm>
-            <a:off x="10456164" y="4872736"/>
-            <a:ext cx="647446" cy="365760"/>
+            <a:off x="9765792" y="5221223"/>
+            <a:ext cx="581660" cy="365760"/>
           </a:xfrm>
           <a:prstGeom prst="roundRect">
             <a:avLst/>
@@ -6333,7 +6376,7 @@
           </a:solidFill>
           <a:ln w="9525">
             <a:solidFill>
-              <a:srgbClr val="2A333E"/>
+              <a:srgbClr val="2A333D"/>
             </a:solidFill>
           </a:ln>
           <a:effectLst/>
@@ -6353,12 +6396,16 @@
           </a:fontRef>
         </p:style>
         <p:txBody>
-          <a:bodyPr rtlCol="0" anchor="ctr" wrap="none" lIns="109728" rIns="73152" tIns="0" bIns="0"/>
-          <a:lstStyle/>
-          <a:p>
-            <a:pPr algn="ctr"/>
-            <a:r>
-              <a:rPr sz="1100">
+          <a:bodyPr rtlCol="0" anchor="ctr" wrap="none" lIns="128016" tIns="0" bIns="0"/>
+          <a:lstStyle/>
+          <a:p>
+            <a:pPr algn="l">
+              <a:lnSpc>
+                <a:spcPct val="100000"/>
+              </a:lnSpc>
+            </a:pPr>
+            <a:r>
+              <a:rPr sz="1100" b="0" i="0">
                 <a:solidFill>
                   <a:srgbClr val="ECEFF3"/>
                 </a:solidFill>
@@ -6377,8 +6424,8 @@
         </p:nvSpPr>
         <p:spPr>
           <a:xfrm>
-            <a:off x="10456164" y="4872736"/>
-            <a:ext cx="36576" cy="365760"/>
+            <a:off x="9765792" y="5221223"/>
+            <a:ext cx="41148" cy="365760"/>
           </a:xfrm>
           <a:prstGeom prst="rect">
             <a:avLst/>
@@ -6421,8 +6468,8 @@
         </p:nvSpPr>
         <p:spPr>
           <a:xfrm>
-            <a:off x="777240" y="5311648"/>
-            <a:ext cx="899858" cy="365760"/>
+            <a:off x="10457179" y="5221223"/>
+            <a:ext cx="812165" cy="365760"/>
           </a:xfrm>
           <a:prstGeom prst="roundRect">
             <a:avLst/>
@@ -6432,7 +6479,7 @@
           </a:solidFill>
           <a:ln w="9525">
             <a:solidFill>
-              <a:srgbClr val="2A333E"/>
+              <a:srgbClr val="2A333D"/>
             </a:solidFill>
           </a:ln>
           <a:effectLst/>
@@ -6452,12 +6499,16 @@
           </a:fontRef>
         </p:style>
         <p:txBody>
-          <a:bodyPr rtlCol="0" anchor="ctr" wrap="none" lIns="109728" rIns="73152" tIns="0" bIns="0"/>
-          <a:lstStyle/>
-          <a:p>
-            <a:pPr algn="ctr"/>
-            <a:r>
-              <a:rPr sz="1100">
+          <a:bodyPr rtlCol="0" anchor="ctr" wrap="none" lIns="128016" tIns="0" bIns="0"/>
+          <a:lstStyle/>
+          <a:p>
+            <a:pPr algn="l">
+              <a:lnSpc>
+                <a:spcPct val="100000"/>
+              </a:lnSpc>
+            </a:pPr>
+            <a:r>
+              <a:rPr sz="1100" b="0" i="0">
                 <a:solidFill>
                   <a:srgbClr val="ECEFF3"/>
                 </a:solidFill>
@@ -6476,8 +6527,8 @@
         </p:nvSpPr>
         <p:spPr>
           <a:xfrm>
-            <a:off x="777240" y="5311648"/>
-            <a:ext cx="36576" cy="365760"/>
+            <a:off x="10457179" y="5221223"/>
+            <a:ext cx="41148" cy="365760"/>
           </a:xfrm>
           <a:prstGeom prst="rect">
             <a:avLst/>
@@ -6520,8 +6571,8 @@
         </p:nvSpPr>
         <p:spPr>
           <a:xfrm>
-            <a:off x="1768538" y="5311648"/>
-            <a:ext cx="1320546" cy="365760"/>
+            <a:off x="777240" y="5678423"/>
+            <a:ext cx="1196340" cy="365760"/>
           </a:xfrm>
           <a:prstGeom prst="roundRect">
             <a:avLst/>
@@ -6531,7 +6582,7 @@
           </a:solidFill>
           <a:ln w="9525">
             <a:solidFill>
-              <a:srgbClr val="2A333E"/>
+              <a:srgbClr val="2A333D"/>
             </a:solidFill>
           </a:ln>
           <a:effectLst/>
@@ -6551,12 +6602,16 @@
           </a:fontRef>
         </p:style>
         <p:txBody>
-          <a:bodyPr rtlCol="0" anchor="ctr" wrap="none" lIns="109728" rIns="73152" tIns="0" bIns="0"/>
-          <a:lstStyle/>
-          <a:p>
-            <a:pPr algn="ctr"/>
-            <a:r>
-              <a:rPr sz="1100">
+          <a:bodyPr rtlCol="0" anchor="ctr" wrap="none" lIns="128016" tIns="0" bIns="0"/>
+          <a:lstStyle/>
+          <a:p>
+            <a:pPr algn="l">
+              <a:lnSpc>
+                <a:spcPct val="100000"/>
+              </a:lnSpc>
+            </a:pPr>
+            <a:r>
+              <a:rPr sz="1100" b="0" i="0">
                 <a:solidFill>
                   <a:srgbClr val="ECEFF3"/>
                 </a:solidFill>
@@ -6575,8 +6630,8 @@
         </p:nvSpPr>
         <p:spPr>
           <a:xfrm>
-            <a:off x="1768538" y="5311648"/>
-            <a:ext cx="36576" cy="365760"/>
+            <a:off x="777240" y="5678423"/>
+            <a:ext cx="41148" cy="365760"/>
           </a:xfrm>
           <a:prstGeom prst="rect">
             <a:avLst/>
@@ -6619,8 +6674,8 @@
         </p:nvSpPr>
         <p:spPr>
           <a:xfrm>
-            <a:off x="3180524" y="5311648"/>
-            <a:ext cx="647446" cy="365760"/>
+            <a:off x="2083308" y="5678423"/>
+            <a:ext cx="581660" cy="365760"/>
           </a:xfrm>
           <a:prstGeom prst="roundRect">
             <a:avLst/>
@@ -6630,7 +6685,7 @@
           </a:solidFill>
           <a:ln w="9525">
             <a:solidFill>
-              <a:srgbClr val="2A333E"/>
+              <a:srgbClr val="2A333D"/>
             </a:solidFill>
           </a:ln>
           <a:effectLst/>
@@ -6650,12 +6705,16 @@
           </a:fontRef>
         </p:style>
         <p:txBody>
-          <a:bodyPr rtlCol="0" anchor="ctr" wrap="none" lIns="109728" rIns="73152" tIns="0" bIns="0"/>
-          <a:lstStyle/>
-          <a:p>
-            <a:pPr algn="ctr"/>
-            <a:r>
-              <a:rPr sz="1100">
+          <a:bodyPr rtlCol="0" anchor="ctr" wrap="none" lIns="128016" tIns="0" bIns="0"/>
+          <a:lstStyle/>
+          <a:p>
+            <a:pPr algn="l">
+              <a:lnSpc>
+                <a:spcPct val="100000"/>
+              </a:lnSpc>
+            </a:pPr>
+            <a:r>
+              <a:rPr sz="1100" b="0" i="0">
                 <a:solidFill>
                   <a:srgbClr val="ECEFF3"/>
                 </a:solidFill>
@@ -6674,8 +6733,8 @@
         </p:nvSpPr>
         <p:spPr>
           <a:xfrm>
-            <a:off x="3180524" y="5311648"/>
-            <a:ext cx="36576" cy="365760"/>
+            <a:off x="2083308" y="5678423"/>
+            <a:ext cx="41148" cy="365760"/>
           </a:xfrm>
           <a:prstGeom prst="rect">
             <a:avLst/>
@@ -6718,8 +6777,8 @@
         </p:nvSpPr>
         <p:spPr>
           <a:xfrm>
-            <a:off x="3919410" y="5311648"/>
-            <a:ext cx="563308" cy="365760"/>
+            <a:off x="2774696" y="5678423"/>
+            <a:ext cx="504825" cy="365760"/>
           </a:xfrm>
           <a:prstGeom prst="roundRect">
             <a:avLst/>
@@ -6729,7 +6788,7 @@
           </a:solidFill>
           <a:ln w="9525">
             <a:solidFill>
-              <a:srgbClr val="2A333E"/>
+              <a:srgbClr val="2A333D"/>
             </a:solidFill>
           </a:ln>
           <a:effectLst/>
@@ -6749,12 +6808,16 @@
           </a:fontRef>
         </p:style>
         <p:txBody>
-          <a:bodyPr rtlCol="0" anchor="ctr" wrap="none" lIns="109728" rIns="73152" tIns="0" bIns="0"/>
-          <a:lstStyle/>
-          <a:p>
-            <a:pPr algn="ctr"/>
-            <a:r>
-              <a:rPr sz="1100">
+          <a:bodyPr rtlCol="0" anchor="ctr" wrap="none" lIns="128016" tIns="0" bIns="0"/>
+          <a:lstStyle/>
+          <a:p>
+            <a:pPr algn="l">
+              <a:lnSpc>
+                <a:spcPct val="100000"/>
+              </a:lnSpc>
+            </a:pPr>
+            <a:r>
+              <a:rPr sz="1100" b="0" i="0">
                 <a:solidFill>
                   <a:srgbClr val="ECEFF3"/>
                 </a:solidFill>
@@ -6773,8 +6836,8 @@
         </p:nvSpPr>
         <p:spPr>
           <a:xfrm>
-            <a:off x="3919410" y="5311648"/>
-            <a:ext cx="36576" cy="365760"/>
+            <a:off x="2774696" y="5678423"/>
+            <a:ext cx="41148" cy="365760"/>
           </a:xfrm>
           <a:prstGeom prst="rect">
             <a:avLst/>
@@ -6817,8 +6880,8 @@
         </p:nvSpPr>
         <p:spPr>
           <a:xfrm>
-            <a:off x="4574159" y="5311648"/>
-            <a:ext cx="2330196" cy="365760"/>
+            <a:off x="3389249" y="5678423"/>
+            <a:ext cx="2118360" cy="365760"/>
           </a:xfrm>
           <a:prstGeom prst="roundRect">
             <a:avLst/>
@@ -6828,7 +6891,7 @@
           </a:solidFill>
           <a:ln w="9525">
             <a:solidFill>
-              <a:srgbClr val="2A333E"/>
+              <a:srgbClr val="2A333D"/>
             </a:solidFill>
           </a:ln>
           <a:effectLst/>
@@ -6848,12 +6911,16 @@
           </a:fontRef>
         </p:style>
         <p:txBody>
-          <a:bodyPr rtlCol="0" anchor="ctr" wrap="none" lIns="109728" rIns="73152" tIns="0" bIns="0"/>
-          <a:lstStyle/>
-          <a:p>
-            <a:pPr algn="ctr"/>
-            <a:r>
-              <a:rPr sz="1100">
+          <a:bodyPr rtlCol="0" anchor="ctr" wrap="none" lIns="128016" tIns="0" bIns="0"/>
+          <a:lstStyle/>
+          <a:p>
+            <a:pPr algn="l">
+              <a:lnSpc>
+                <a:spcPct val="100000"/>
+              </a:lnSpc>
+            </a:pPr>
+            <a:r>
+              <a:rPr sz="1100" b="0" i="0">
                 <a:solidFill>
                   <a:srgbClr val="ECEFF3"/>
                 </a:solidFill>
@@ -6872,8 +6939,8 @@
         </p:nvSpPr>
         <p:spPr>
           <a:xfrm>
-            <a:off x="4574159" y="5311648"/>
-            <a:ext cx="36576" cy="365760"/>
+            <a:off x="3389249" y="5678423"/>
+            <a:ext cx="41148" cy="365760"/>
           </a:xfrm>
           <a:prstGeom prst="rect">
             <a:avLst/>
@@ -6916,8 +6983,8 @@
         </p:nvSpPr>
         <p:spPr>
           <a:xfrm>
-            <a:off x="6995795" y="5311648"/>
-            <a:ext cx="1236408" cy="365760"/>
+            <a:off x="5617337" y="5678423"/>
+            <a:ext cx="1119505" cy="365760"/>
           </a:xfrm>
           <a:prstGeom prst="roundRect">
             <a:avLst/>
@@ -6927,7 +6994,7 @@
           </a:solidFill>
           <a:ln w="9525">
             <a:solidFill>
-              <a:srgbClr val="2A333E"/>
+              <a:srgbClr val="2A333D"/>
             </a:solidFill>
           </a:ln>
           <a:effectLst/>
@@ -6947,12 +7014,16 @@
           </a:fontRef>
         </p:style>
         <p:txBody>
-          <a:bodyPr rtlCol="0" anchor="ctr" wrap="none" lIns="109728" rIns="73152" tIns="0" bIns="0"/>
-          <a:lstStyle/>
-          <a:p>
-            <a:pPr algn="ctr"/>
-            <a:r>
-              <a:rPr sz="1100">
+          <a:bodyPr rtlCol="0" anchor="ctr" wrap="none" lIns="128016" tIns="0" bIns="0"/>
+          <a:lstStyle/>
+          <a:p>
+            <a:pPr algn="l">
+              <a:lnSpc>
+                <a:spcPct val="100000"/>
+              </a:lnSpc>
+            </a:pPr>
+            <a:r>
+              <a:rPr sz="1100" b="0" i="0">
                 <a:solidFill>
                   <a:srgbClr val="ECEFF3"/>
                 </a:solidFill>
@@ -6971,8 +7042,8 @@
         </p:nvSpPr>
         <p:spPr>
           <a:xfrm>
-            <a:off x="6995795" y="5311648"/>
-            <a:ext cx="36576" cy="365760"/>
+            <a:off x="5617337" y="5678423"/>
+            <a:ext cx="41148" cy="365760"/>
           </a:xfrm>
           <a:prstGeom prst="rect">
             <a:avLst/>
@@ -7015,8 +7086,8 @@
         </p:nvSpPr>
         <p:spPr>
           <a:xfrm>
-            <a:off x="8323643" y="5311648"/>
-            <a:ext cx="1909508" cy="365760"/>
+            <a:off x="6846570" y="5678423"/>
+            <a:ext cx="1734185" cy="365760"/>
           </a:xfrm>
           <a:prstGeom prst="roundRect">
             <a:avLst/>
@@ -7026,7 +7097,7 @@
           </a:solidFill>
           <a:ln w="9525">
             <a:solidFill>
-              <a:srgbClr val="2A333E"/>
+              <a:srgbClr val="2A333D"/>
             </a:solidFill>
           </a:ln>
           <a:effectLst/>
@@ -7046,12 +7117,16 @@
           </a:fontRef>
         </p:style>
         <p:txBody>
-          <a:bodyPr rtlCol="0" anchor="ctr" wrap="none" lIns="109728" rIns="73152" tIns="0" bIns="0"/>
-          <a:lstStyle/>
-          <a:p>
-            <a:pPr algn="ctr"/>
-            <a:r>
-              <a:rPr sz="1100">
+          <a:bodyPr rtlCol="0" anchor="ctr" wrap="none" lIns="128016" tIns="0" bIns="0"/>
+          <a:lstStyle/>
+          <a:p>
+            <a:pPr algn="l">
+              <a:lnSpc>
+                <a:spcPct val="100000"/>
+              </a:lnSpc>
+            </a:pPr>
+            <a:r>
+              <a:rPr sz="1100" b="0" i="0">
                 <a:solidFill>
                   <a:srgbClr val="ECEFF3"/>
                 </a:solidFill>
@@ -7070,8 +7145,8 @@
         </p:nvSpPr>
         <p:spPr>
           <a:xfrm>
-            <a:off x="8323643" y="5311648"/>
-            <a:ext cx="36576" cy="365760"/>
+            <a:off x="6846570" y="5678423"/>
+            <a:ext cx="41148" cy="365760"/>
           </a:xfrm>
           <a:prstGeom prst="rect">
             <a:avLst/>
@@ -7114,8 +7189,8 @@
         </p:nvSpPr>
         <p:spPr>
           <a:xfrm>
-            <a:off x="777240" y="5750560"/>
-            <a:ext cx="1488821" cy="365760"/>
+            <a:off x="8690483" y="5678423"/>
+            <a:ext cx="1350010" cy="365760"/>
           </a:xfrm>
           <a:prstGeom prst="roundRect">
             <a:avLst/>
@@ -7125,7 +7200,7 @@
           </a:solidFill>
           <a:ln w="9525">
             <a:solidFill>
-              <a:srgbClr val="2A333E"/>
+              <a:srgbClr val="2A333D"/>
             </a:solidFill>
           </a:ln>
           <a:effectLst/>
@@ -7145,12 +7220,16 @@
           </a:fontRef>
         </p:style>
         <p:txBody>
-          <a:bodyPr rtlCol="0" anchor="ctr" wrap="none" lIns="109728" rIns="73152" tIns="0" bIns="0"/>
-          <a:lstStyle/>
-          <a:p>
-            <a:pPr algn="ctr"/>
-            <a:r>
-              <a:rPr sz="1100">
+          <a:bodyPr rtlCol="0" anchor="ctr" wrap="none" lIns="128016" tIns="0" bIns="0"/>
+          <a:lstStyle/>
+          <a:p>
+            <a:pPr algn="l">
+              <a:lnSpc>
+                <a:spcPct val="100000"/>
+              </a:lnSpc>
+            </a:pPr>
+            <a:r>
+              <a:rPr sz="1100" b="0" i="0">
                 <a:solidFill>
                   <a:srgbClr val="ECEFF3"/>
                 </a:solidFill>
@@ -7169,8 +7248,8 @@
         </p:nvSpPr>
         <p:spPr>
           <a:xfrm>
-            <a:off x="777240" y="5750560"/>
-            <a:ext cx="36576" cy="365760"/>
+            <a:off x="8690483" y="5678423"/>
+            <a:ext cx="41148" cy="365760"/>
           </a:xfrm>
           <a:prstGeom prst="rect">
             <a:avLst/>
@@ -7240,7 +7319,7 @@
         <p:spPr>
           <a:xfrm>
             <a:off x="0" y="0"/>
-            <a:ext cx="12191695" cy="38100"/>
+            <a:ext cx="5486400" cy="38100"/>
           </a:xfrm>
           <a:prstGeom prst="rect">
             <a:avLst/>
@@ -7277,14 +7356,60 @@
       </p:sp>
       <p:sp>
         <p:nvSpPr>
-          <p:cNvPr id="3" name="TextBox 2"/>
+          <p:cNvPr id="3" name="Rounded Rectangle 2"/>
+          <p:cNvSpPr/>
+          <p:nvPr/>
+        </p:nvSpPr>
+        <p:spPr>
+          <a:xfrm>
+            <a:off x="777240" y="1051560"/>
+            <a:ext cx="3749039" cy="5029200"/>
+          </a:xfrm>
+          <a:prstGeom prst="roundRect">
+            <a:avLst/>
+          </a:prstGeom>
+          <a:solidFill>
+            <a:srgbClr val="06090C"/>
+          </a:solidFill>
+          <a:ln w="9525">
+            <a:solidFill>
+              <a:srgbClr val="C98A2E"/>
+            </a:solidFill>
+          </a:ln>
+          <a:effectLst/>
+        </p:spPr>
+        <p:style>
+          <a:lnRef idx="1">
+            <a:schemeClr val="accent1"/>
+          </a:lnRef>
+          <a:fillRef idx="3">
+            <a:schemeClr val="accent1"/>
+          </a:fillRef>
+          <a:effectRef idx="2">
+            <a:schemeClr val="accent1"/>
+          </a:effectRef>
+          <a:fontRef idx="minor">
+            <a:schemeClr val="lt1"/>
+          </a:fontRef>
+        </p:style>
+        <p:txBody>
+          <a:bodyPr rtlCol="0" anchor="ctr"/>
+          <a:lstStyle/>
+          <a:p>
+            <a:pPr algn="ctr"/>
+          </a:p>
+        </p:txBody>
+      </p:sp>
+      <p:sp>
+        <p:nvSpPr>
+          <p:cNvPr id="4" name="TextBox 3"/>
           <p:cNvSpPr txBox="1"/>
           <p:nvPr/>
         </p:nvSpPr>
         <p:spPr>
           <a:xfrm>
-            <a:off x="777240" y="3344672"/>
-            <a:ext cx="10607040" cy="534416"/>
+            <a:off x="886968" y="1106424"/>
+            <a:ext cx="3529583" cy="256032"/>
           </a:xfrm>
           <a:prstGeom prst="rect">
             <a:avLst/>
@@ -7292,21 +7417,223 @@
           <a:noFill/>
         </p:spPr>
         <p:txBody>
-          <a:bodyPr wrap="square" lIns="25400" rIns="25400" tIns="12700" bIns="12700">
-            <a:noAutofit/>
+          <a:bodyPr wrap="square" anchor="ctr" lIns="0" rIns="0" tIns="0" bIns="0">
+            <a:spAutoFit/>
           </a:bodyPr>
           <a:lstStyle/>
           <a:p>
             <a:pPr algn="l">
               <a:lnSpc>
-                <a:spcPct val="106000"/>
+                <a:spcPct val="100000"/>
               </a:lnSpc>
-              <a:spcAft>
-                <a:spcPts val="400"/>
-              </a:spcAft>
             </a:pPr>
             <a:r>
-              <a:rPr sz="2600" b="0">
+              <a:rPr sz="900" b="0" i="0">
+                <a:solidFill>
+                  <a:srgbClr val="9DA9B5"/>
+                </a:solidFill>
+                <a:latin typeface="Consolas"/>
+              </a:rPr>
+              <a:t>R MLO · screening</a:t>
+            </a:r>
+          </a:p>
+        </p:txBody>
+      </p:sp>
+      <p:sp>
+        <p:nvSpPr>
+          <p:cNvPr id="5" name="TextBox 4"/>
+          <p:cNvSpPr txBox="1"/>
+          <p:nvPr/>
+        </p:nvSpPr>
+        <p:spPr>
+          <a:xfrm>
+            <a:off x="886968" y="1106424"/>
+            <a:ext cx="3529583" cy="256032"/>
+          </a:xfrm>
+          <a:prstGeom prst="rect">
+            <a:avLst/>
+          </a:prstGeom>
+          <a:noFill/>
+        </p:spPr>
+        <p:txBody>
+          <a:bodyPr wrap="square" anchor="ctr" lIns="0" rIns="0" tIns="0" bIns="0">
+            <a:spAutoFit/>
+          </a:bodyPr>
+          <a:lstStyle/>
+          <a:p>
+            <a:pPr algn="r">
+              <a:lnSpc>
+                <a:spcPct val="100000"/>
+              </a:lnSpc>
+            </a:pPr>
+            <a:r>
+              <a:rPr sz="900" b="0" i="0">
+                <a:solidFill>
+                  <a:srgbClr val="5FB7C9"/>
+                </a:solidFill>
+                <a:latin typeface="Consolas"/>
+              </a:rPr>
+              <a:t>AI —</a:t>
+            </a:r>
+          </a:p>
+        </p:txBody>
+      </p:sp>
+      <p:sp>
+        <p:nvSpPr>
+          <p:cNvPr id="6" name="Rectangle 5"/>
+          <p:cNvSpPr/>
+          <p:nvPr/>
+        </p:nvSpPr>
+        <p:spPr>
+          <a:xfrm>
+            <a:off x="850392" y="1435607"/>
+            <a:ext cx="3602735" cy="12700"/>
+          </a:xfrm>
+          <a:prstGeom prst="rect">
+            <a:avLst/>
+          </a:prstGeom>
+          <a:solidFill>
+            <a:srgbClr val="2A333D"/>
+          </a:solidFill>
+          <a:ln>
+            <a:noFill/>
+          </a:ln>
+          <a:effectLst/>
+        </p:spPr>
+        <p:style>
+          <a:lnRef idx="1">
+            <a:schemeClr val="accent1"/>
+          </a:lnRef>
+          <a:fillRef idx="3">
+            <a:schemeClr val="accent1"/>
+          </a:fillRef>
+          <a:effectRef idx="2">
+            <a:schemeClr val="accent1"/>
+          </a:effectRef>
+          <a:fontRef idx="minor">
+            <a:schemeClr val="lt1"/>
+          </a:fontRef>
+        </p:style>
+        <p:txBody>
+          <a:bodyPr rtlCol="0" anchor="ctr"/>
+          <a:lstStyle/>
+          <a:p>
+            <a:pPr algn="ctr"/>
+          </a:p>
+        </p:txBody>
+      </p:sp>
+      <p:sp>
+        <p:nvSpPr>
+          <p:cNvPr id="7" name="Rectangle 6"/>
+          <p:cNvSpPr/>
+          <p:nvPr/>
+        </p:nvSpPr>
+        <p:spPr>
+          <a:xfrm>
+            <a:off x="886968" y="1527048"/>
+            <a:ext cx="3529583" cy="4425696"/>
+          </a:xfrm>
+          <a:prstGeom prst="rect">
+            <a:avLst/>
+          </a:prstGeom>
+          <a:solidFill>
+            <a:srgbClr val="000000"/>
+          </a:solidFill>
+          <a:ln>
+            <a:noFill/>
+          </a:ln>
+          <a:effectLst/>
+        </p:spPr>
+        <p:style>
+          <a:lnRef idx="1">
+            <a:schemeClr val="accent1"/>
+          </a:lnRef>
+          <a:fillRef idx="3">
+            <a:schemeClr val="accent1"/>
+          </a:fillRef>
+          <a:effectRef idx="2">
+            <a:schemeClr val="accent1"/>
+          </a:effectRef>
+          <a:fontRef idx="minor">
+            <a:schemeClr val="lt1"/>
+          </a:fontRef>
+        </p:style>
+        <p:txBody>
+          <a:bodyPr rtlCol="0" anchor="ctr"/>
+          <a:lstStyle/>
+          <a:p>
+            <a:pPr algn="ctr"/>
+          </a:p>
+        </p:txBody>
+      </p:sp>
+      <p:sp>
+        <p:nvSpPr>
+          <p:cNvPr id="8" name="TextBox 7"/>
+          <p:cNvSpPr txBox="1"/>
+          <p:nvPr/>
+        </p:nvSpPr>
+        <p:spPr>
+          <a:xfrm>
+            <a:off x="941832" y="5696712"/>
+            <a:ext cx="3419856" cy="274320"/>
+          </a:xfrm>
+          <a:prstGeom prst="rect">
+            <a:avLst/>
+          </a:prstGeom>
+          <a:noFill/>
+        </p:spPr>
+        <p:txBody>
+          <a:bodyPr wrap="square" anchor="t" lIns="0" rIns="0" tIns="0" bIns="0">
+            <a:spAutoFit/>
+          </a:bodyPr>
+          <a:lstStyle/>
+          <a:p>
+            <a:pPr algn="l">
+              <a:lnSpc>
+                <a:spcPct val="100000"/>
+              </a:lnSpc>
+            </a:pPr>
+            <a:r>
+              <a:rPr sz="800" b="0" i="0">
+                <a:solidFill>
+                  <a:srgbClr val="5C6975"/>
+                </a:solidFill>
+                <a:latin typeface="Consolas"/>
+              </a:rPr>
+              <a:t>[ de-identified Emory screening case ]</a:t>
+            </a:r>
+          </a:p>
+        </p:txBody>
+      </p:sp>
+      <p:sp>
+        <p:nvSpPr>
+          <p:cNvPr id="9" name="TextBox 8"/>
+          <p:cNvSpPr txBox="1"/>
+          <p:nvPr/>
+        </p:nvSpPr>
+        <p:spPr>
+          <a:xfrm>
+            <a:off x="5074920" y="2286000"/>
+            <a:ext cx="6400800" cy="2194560"/>
+          </a:xfrm>
+          <a:prstGeom prst="rect">
+            <a:avLst/>
+          </a:prstGeom>
+          <a:noFill/>
+        </p:spPr>
+        <p:txBody>
+          <a:bodyPr wrap="square" anchor="t" lIns="0" rIns="0" tIns="0" bIns="0">
+            <a:spAutoFit/>
+          </a:bodyPr>
+          <a:lstStyle/>
+          <a:p>
+            <a:pPr algn="l">
+              <a:lnSpc>
+                <a:spcPct val="112000"/>
+              </a:lnSpc>
+            </a:pPr>
+            <a:r>
+              <a:rPr sz="3400" b="1" i="0">
                 <a:solidFill>
                   <a:srgbClr val="ECEFF3"/>
                 </a:solidFill>
@@ -7352,7 +7679,7 @@
         <p:spPr>
           <a:xfrm>
             <a:off x="0" y="0"/>
-            <a:ext cx="12191695" cy="38100"/>
+            <a:ext cx="5486400" cy="38100"/>
           </a:xfrm>
           <a:prstGeom prst="rect">
             <a:avLst/>
@@ -7389,14 +7716,60 @@
       </p:sp>
       <p:sp>
         <p:nvSpPr>
-          <p:cNvPr id="3" name="TextBox 2"/>
+          <p:cNvPr id="3" name="Rounded Rectangle 2"/>
+          <p:cNvSpPr/>
+          <p:nvPr/>
+        </p:nvSpPr>
+        <p:spPr>
+          <a:xfrm>
+            <a:off x="777240" y="914400"/>
+            <a:ext cx="3246120" cy="5120640"/>
+          </a:xfrm>
+          <a:prstGeom prst="roundRect">
+            <a:avLst/>
+          </a:prstGeom>
+          <a:solidFill>
+            <a:srgbClr val="06090C"/>
+          </a:solidFill>
+          <a:ln w="9525">
+            <a:solidFill>
+              <a:srgbClr val="C98A2E"/>
+            </a:solidFill>
+          </a:ln>
+          <a:effectLst/>
+        </p:spPr>
+        <p:style>
+          <a:lnRef idx="1">
+            <a:schemeClr val="accent1"/>
+          </a:lnRef>
+          <a:fillRef idx="3">
+            <a:schemeClr val="accent1"/>
+          </a:fillRef>
+          <a:effectRef idx="2">
+            <a:schemeClr val="accent1"/>
+          </a:effectRef>
+          <a:fontRef idx="minor">
+            <a:schemeClr val="lt1"/>
+          </a:fontRef>
+        </p:style>
+        <p:txBody>
+          <a:bodyPr rtlCol="0" anchor="ctr"/>
+          <a:lstStyle/>
+          <a:p>
+            <a:pPr algn="ctr"/>
+          </a:p>
+        </p:txBody>
+      </p:sp>
+      <p:sp>
+        <p:nvSpPr>
+          <p:cNvPr id="4" name="TextBox 3"/>
           <p:cNvSpPr txBox="1"/>
           <p:nvPr/>
         </p:nvSpPr>
         <p:spPr>
           <a:xfrm>
-            <a:off x="777240" y="3171444"/>
-            <a:ext cx="10607040" cy="534416"/>
+            <a:off x="886968" y="969264"/>
+            <a:ext cx="3026663" cy="256032"/>
           </a:xfrm>
           <a:prstGeom prst="rect">
             <a:avLst/>
@@ -7404,21 +7777,223 @@
           <a:noFill/>
         </p:spPr>
         <p:txBody>
-          <a:bodyPr wrap="square" lIns="25400" rIns="25400" tIns="12700" bIns="12700">
-            <a:noAutofit/>
+          <a:bodyPr wrap="square" anchor="ctr" lIns="0" rIns="0" tIns="0" bIns="0">
+            <a:spAutoFit/>
           </a:bodyPr>
           <a:lstStyle/>
           <a:p>
             <a:pPr algn="l">
               <a:lnSpc>
-                <a:spcPct val="106000"/>
+                <a:spcPct val="100000"/>
               </a:lnSpc>
-              <a:spcAft>
-                <a:spcPts val="400"/>
-              </a:spcAft>
             </a:pPr>
             <a:r>
-              <a:rPr sz="2600" b="0">
+              <a:rPr sz="900" b="0" i="0">
+                <a:solidFill>
+                  <a:srgbClr val="9DA9B5"/>
+                </a:solidFill>
+                <a:latin typeface="Consolas"/>
+              </a:rPr>
+              <a:t>R MLO · screening</a:t>
+            </a:r>
+          </a:p>
+        </p:txBody>
+      </p:sp>
+      <p:sp>
+        <p:nvSpPr>
+          <p:cNvPr id="5" name="TextBox 4"/>
+          <p:cNvSpPr txBox="1"/>
+          <p:nvPr/>
+        </p:nvSpPr>
+        <p:spPr>
+          <a:xfrm>
+            <a:off x="886968" y="969264"/>
+            <a:ext cx="3026663" cy="256032"/>
+          </a:xfrm>
+          <a:prstGeom prst="rect">
+            <a:avLst/>
+          </a:prstGeom>
+          <a:noFill/>
+        </p:spPr>
+        <p:txBody>
+          <a:bodyPr wrap="square" anchor="ctr" lIns="0" rIns="0" tIns="0" bIns="0">
+            <a:spAutoFit/>
+          </a:bodyPr>
+          <a:lstStyle/>
+          <a:p>
+            <a:pPr algn="r">
+              <a:lnSpc>
+                <a:spcPct val="100000"/>
+              </a:lnSpc>
+            </a:pPr>
+            <a:r>
+              <a:rPr sz="900" b="0" i="0">
+                <a:solidFill>
+                  <a:srgbClr val="5FB7C9"/>
+                </a:solidFill>
+                <a:latin typeface="Consolas"/>
+              </a:rPr>
+              <a:t>AI ✓✓✓</a:t>
+            </a:r>
+          </a:p>
+        </p:txBody>
+      </p:sp>
+      <p:sp>
+        <p:nvSpPr>
+          <p:cNvPr id="6" name="Rectangle 5"/>
+          <p:cNvSpPr/>
+          <p:nvPr/>
+        </p:nvSpPr>
+        <p:spPr>
+          <a:xfrm>
+            <a:off x="850392" y="1298448"/>
+            <a:ext cx="3099815" cy="12700"/>
+          </a:xfrm>
+          <a:prstGeom prst="rect">
+            <a:avLst/>
+          </a:prstGeom>
+          <a:solidFill>
+            <a:srgbClr val="2A333D"/>
+          </a:solidFill>
+          <a:ln>
+            <a:noFill/>
+          </a:ln>
+          <a:effectLst/>
+        </p:spPr>
+        <p:style>
+          <a:lnRef idx="1">
+            <a:schemeClr val="accent1"/>
+          </a:lnRef>
+          <a:fillRef idx="3">
+            <a:schemeClr val="accent1"/>
+          </a:fillRef>
+          <a:effectRef idx="2">
+            <a:schemeClr val="accent1"/>
+          </a:effectRef>
+          <a:fontRef idx="minor">
+            <a:schemeClr val="lt1"/>
+          </a:fontRef>
+        </p:style>
+        <p:txBody>
+          <a:bodyPr rtlCol="0" anchor="ctr"/>
+          <a:lstStyle/>
+          <a:p>
+            <a:pPr algn="ctr"/>
+          </a:p>
+        </p:txBody>
+      </p:sp>
+      <p:sp>
+        <p:nvSpPr>
+          <p:cNvPr id="7" name="Rectangle 6"/>
+          <p:cNvSpPr/>
+          <p:nvPr/>
+        </p:nvSpPr>
+        <p:spPr>
+          <a:xfrm>
+            <a:off x="886968" y="1389888"/>
+            <a:ext cx="3026663" cy="4517136"/>
+          </a:xfrm>
+          <a:prstGeom prst="rect">
+            <a:avLst/>
+          </a:prstGeom>
+          <a:solidFill>
+            <a:srgbClr val="000000"/>
+          </a:solidFill>
+          <a:ln>
+            <a:noFill/>
+          </a:ln>
+          <a:effectLst/>
+        </p:spPr>
+        <p:style>
+          <a:lnRef idx="1">
+            <a:schemeClr val="accent1"/>
+          </a:lnRef>
+          <a:fillRef idx="3">
+            <a:schemeClr val="accent1"/>
+          </a:fillRef>
+          <a:effectRef idx="2">
+            <a:schemeClr val="accent1"/>
+          </a:effectRef>
+          <a:fontRef idx="minor">
+            <a:schemeClr val="lt1"/>
+          </a:fontRef>
+        </p:style>
+        <p:txBody>
+          <a:bodyPr rtlCol="0" anchor="ctr"/>
+          <a:lstStyle/>
+          <a:p>
+            <a:pPr algn="ctr"/>
+          </a:p>
+        </p:txBody>
+      </p:sp>
+      <p:sp>
+        <p:nvSpPr>
+          <p:cNvPr id="8" name="TextBox 7"/>
+          <p:cNvSpPr txBox="1"/>
+          <p:nvPr/>
+        </p:nvSpPr>
+        <p:spPr>
+          <a:xfrm>
+            <a:off x="941832" y="5650992"/>
+            <a:ext cx="2916936" cy="274320"/>
+          </a:xfrm>
+          <a:prstGeom prst="rect">
+            <a:avLst/>
+          </a:prstGeom>
+          <a:noFill/>
+        </p:spPr>
+        <p:txBody>
+          <a:bodyPr wrap="square" anchor="t" lIns="0" rIns="0" tIns="0" bIns="0">
+            <a:spAutoFit/>
+          </a:bodyPr>
+          <a:lstStyle/>
+          <a:p>
+            <a:pPr algn="l">
+              <a:lnSpc>
+                <a:spcPct val="100000"/>
+              </a:lnSpc>
+            </a:pPr>
+            <a:r>
+              <a:rPr sz="800" b="0" i="0">
+                <a:solidFill>
+                  <a:srgbClr val="5C6975"/>
+                </a:solidFill>
+                <a:latin typeface="Consolas"/>
+              </a:rPr>
+              <a:t>[ de-identified Emory screening case ]</a:t>
+            </a:r>
+          </a:p>
+        </p:txBody>
+      </p:sp>
+      <p:sp>
+        <p:nvSpPr>
+          <p:cNvPr id="9" name="TextBox 8"/>
+          <p:cNvSpPr txBox="1"/>
+          <p:nvPr/>
+        </p:nvSpPr>
+        <p:spPr>
+          <a:xfrm>
+            <a:off x="4526280" y="1828800"/>
+            <a:ext cx="6903720" cy="1280160"/>
+          </a:xfrm>
+          <a:prstGeom prst="rect">
+            <a:avLst/>
+          </a:prstGeom>
+          <a:noFill/>
+        </p:spPr>
+        <p:txBody>
+          <a:bodyPr wrap="square" anchor="t" lIns="0" rIns="0" tIns="0" bIns="0">
+            <a:spAutoFit/>
+          </a:bodyPr>
+          <a:lstStyle/>
+          <a:p>
+            <a:pPr algn="l">
+              <a:lnSpc>
+                <a:spcPct val="105000"/>
+              </a:lnSpc>
+            </a:pPr>
+            <a:r>
+              <a:rPr sz="4000" b="1" i="0">
                 <a:solidFill>
                   <a:srgbClr val="ECEFF3"/>
                 </a:solidFill>
@@ -7427,7 +8002,7 @@
               <a:t>What are we </a:t>
             </a:r>
             <a:r>
-              <a:rPr sz="2600" b="0">
+              <a:rPr sz="4000" b="1" i="0">
                 <a:solidFill>
                   <a:srgbClr val="E7AC51"/>
                 </a:solidFill>
@@ -7440,14 +8015,14 @@
       </p:sp>
       <p:sp>
         <p:nvSpPr>
-          <p:cNvPr id="4" name="TextBox 3"/>
+          <p:cNvPr id="10" name="TextBox 9"/>
           <p:cNvSpPr txBox="1"/>
           <p:nvPr/>
         </p:nvSpPr>
         <p:spPr>
           <a:xfrm>
-            <a:off x="777240" y="3705860"/>
-            <a:ext cx="10607040" cy="346456"/>
+            <a:off x="4526280" y="3246120"/>
+            <a:ext cx="6903720" cy="1463040"/>
           </a:xfrm>
           <a:prstGeom prst="rect">
             <a:avLst/>
@@ -7455,30 +8030,27 @@
           <a:noFill/>
         </p:spPr>
         <p:txBody>
-          <a:bodyPr wrap="square" lIns="25400" rIns="25400" tIns="12700" bIns="12700">
-            <a:noAutofit/>
+          <a:bodyPr wrap="square" anchor="t" lIns="0" rIns="0" tIns="0" bIns="0">
+            <a:spAutoFit/>
           </a:bodyPr>
           <a:lstStyle/>
           <a:p>
             <a:pPr algn="l">
               <a:lnSpc>
-                <a:spcPct val="128000"/>
+                <a:spcPct val="132000"/>
               </a:lnSpc>
-              <a:spcAft>
-                <a:spcPts val="400"/>
-              </a:spcAft>
             </a:pPr>
             <a:r>
-              <a:rPr sz="1400" b="0">
+              <a:rPr sz="1800" b="0" i="0">
                 <a:solidFill>
-                  <a:srgbClr val="9DA9B5"/>
+                  <a:srgbClr val="ECEFF3"/>
                 </a:solidFill>
                 <a:latin typeface="Arial"/>
               </a:rPr>
               <a:t>AI reads this </a:t>
             </a:r>
             <a:r>
-              <a:rPr sz="1400" b="0">
+              <a:rPr sz="1800" b="1" i="0">
                 <a:solidFill>
                   <a:srgbClr val="E7AC51"/>
                 </a:solidFill>
@@ -7487,16 +8059,16 @@
               <a:t>same mammogram</a:t>
             </a:r>
             <a:r>
-              <a:rPr sz="1400" b="0">
+              <a:rPr sz="1800" b="0" i="0">
                 <a:solidFill>
-                  <a:srgbClr val="9DA9B5"/>
+                  <a:srgbClr val="ECEFF3"/>
                 </a:solidFill>
                 <a:latin typeface="Arial"/>
               </a:rPr>
               <a:t> and her biopsy slide — not just the </a:t>
             </a:r>
             <a:r>
-              <a:rPr sz="1400" b="1">
+              <a:rPr sz="1800" b="1" i="0">
                 <a:solidFill>
                   <a:srgbClr val="ECEFF3"/>
                 </a:solidFill>
@@ -7505,16 +8077,16 @@
               <a:t>lesion</a:t>
             </a:r>
             <a:r>
-              <a:rPr sz="1400" b="0">
+              <a:rPr sz="1800" b="0" i="0">
                 <a:solidFill>
-                  <a:srgbClr val="9DA9B5"/>
+                  <a:srgbClr val="ECEFF3"/>
                 </a:solidFill>
                 <a:latin typeface="Arial"/>
               </a:rPr>
               <a:t>, but the </a:t>
             </a:r>
             <a:r>
-              <a:rPr sz="1400" b="0">
+              <a:rPr sz="1800" b="1" i="0">
                 <a:solidFill>
                   <a:srgbClr val="E7AC51"/>
                 </a:solidFill>
@@ -7560,7 +8132,7 @@
         <p:spPr>
           <a:xfrm>
             <a:off x="0" y="0"/>
-            <a:ext cx="12191695" cy="38100"/>
+            <a:ext cx="5486400" cy="38100"/>
           </a:xfrm>
           <a:prstGeom prst="rect">
             <a:avLst/>
@@ -7603,8 +8175,8 @@
         </p:nvSpPr>
         <p:spPr>
           <a:xfrm>
-            <a:off x="777240" y="1325880"/>
-            <a:ext cx="10607040" cy="914400"/>
+            <a:off x="777240" y="1371600"/>
+            <a:ext cx="10607040" cy="1097280"/>
           </a:xfrm>
           <a:prstGeom prst="rect">
             <a:avLst/>
@@ -7612,8 +8184,8 @@
           <a:noFill/>
         </p:spPr>
         <p:txBody>
-          <a:bodyPr wrap="square" lIns="25400" rIns="25400" tIns="12700" bIns="12700">
-            <a:noAutofit/>
+          <a:bodyPr wrap="square" anchor="t" lIns="0" rIns="0" tIns="0" bIns="0">
+            <a:spAutoFit/>
           </a:bodyPr>
           <a:lstStyle/>
           <a:p>
@@ -7621,12 +8193,9 @@
               <a:lnSpc>
                 <a:spcPct val="104000"/>
               </a:lnSpc>
-              <a:spcAft>
-                <a:spcPts val="400"/>
-              </a:spcAft>
             </a:pPr>
             <a:r>
-              <a:rPr sz="4400" b="0">
+              <a:rPr sz="4400" b="1" i="0">
                 <a:solidFill>
                   <a:srgbClr val="ECEFF3"/>
                 </a:solidFill>
@@ -7635,7 +8204,7 @@
               <a:t>From lesions to </a:t>
             </a:r>
             <a:r>
-              <a:rPr sz="4400" b="0">
+              <a:rPr sz="4400" b="1" i="0">
                 <a:solidFill>
                   <a:srgbClr val="E7AC51"/>
                 </a:solidFill>
@@ -7654,7 +8223,7 @@
         </p:nvSpPr>
         <p:spPr>
           <a:xfrm>
-            <a:off x="777240" y="3063240"/>
+            <a:off x="777240" y="3017520"/>
             <a:ext cx="3429000" cy="2286000"/>
           </a:xfrm>
           <a:prstGeom prst="roundRect">
@@ -7665,7 +8234,7 @@
           </a:solidFill>
           <a:ln w="15875">
             <a:solidFill>
-              <a:srgbClr val="2A333E"/>
+              <a:srgbClr val="2A333D"/>
             </a:solidFill>
           </a:ln>
           <a:effectLst/>
@@ -7685,7 +8254,7 @@
           </a:fontRef>
         </p:style>
         <p:txBody>
-          <a:bodyPr rtlCol="0" anchor="t" wrap="square" lIns="256032" rIns="219456" tIns="384048" bIns="182880"/>
+          <a:bodyPr rtlCol="0" anchor="t" wrap="square" lIns="256032" rIns="219456" tIns="411480" bIns="182880"/>
           <a:lstStyle/>
           <a:p>
             <a:pPr algn="l">
@@ -7694,7 +8263,7 @@
               </a:lnSpc>
             </a:pPr>
             <a:r>
-              <a:rPr sz="1100" b="0">
+              <a:rPr sz="1100" b="0" i="0">
                 <a:solidFill>
                   <a:srgbClr val="5C6975"/>
                 </a:solidFill>
@@ -7713,7 +8282,7 @@
               </a:spcBef>
             </a:pPr>
             <a:r>
-              <a:rPr sz="1000" b="1">
+              <a:rPr sz="1000" b="1" i="0">
                 <a:solidFill>
                   <a:srgbClr val="E7AC51"/>
                 </a:solidFill>
@@ -7732,7 +8301,7 @@
               </a:spcBef>
             </a:pPr>
             <a:r>
-              <a:rPr sz="2600" b="1">
+              <a:rPr sz="2600" b="1" i="0">
                 <a:solidFill>
                   <a:srgbClr val="ECEFF3"/>
                 </a:solidFill>
@@ -7751,7 +8320,7 @@
               </a:spcBef>
             </a:pPr>
             <a:r>
-              <a:rPr sz="1250" b="0">
+              <a:rPr sz="1250" b="0" i="0">
                 <a:solidFill>
                   <a:srgbClr val="9DA9B5"/>
                 </a:solidFill>
@@ -7770,8 +8339,8 @@
         </p:nvSpPr>
         <p:spPr>
           <a:xfrm>
-            <a:off x="1005840" y="3264408"/>
-            <a:ext cx="411480" cy="31750"/>
+            <a:off x="1005840" y="3218688"/>
+            <a:ext cx="411480" cy="32004"/>
           </a:xfrm>
           <a:prstGeom prst="rect">
             <a:avLst/>
@@ -7814,7 +8383,7 @@
         </p:nvSpPr>
         <p:spPr>
           <a:xfrm>
-            <a:off x="4457700" y="3063240"/>
+            <a:off x="4457700" y="3017520"/>
             <a:ext cx="3429000" cy="2286000"/>
           </a:xfrm>
           <a:prstGeom prst="roundRect">
@@ -7845,7 +8414,7 @@
           </a:fontRef>
         </p:style>
         <p:txBody>
-          <a:bodyPr rtlCol="0" anchor="t" wrap="square" lIns="256032" rIns="219456" tIns="384048" bIns="182880"/>
+          <a:bodyPr rtlCol="0" anchor="t" wrap="square" lIns="256032" rIns="219456" tIns="411480" bIns="182880"/>
           <a:lstStyle/>
           <a:p>
             <a:pPr algn="l">
@@ -7854,7 +8423,7 @@
               </a:lnSpc>
             </a:pPr>
             <a:r>
-              <a:rPr sz="1100" b="0">
+              <a:rPr sz="1100" b="0" i="0">
                 <a:solidFill>
                   <a:srgbClr val="5C6975"/>
                 </a:solidFill>
@@ -7873,7 +8442,7 @@
               </a:spcBef>
             </a:pPr>
             <a:r>
-              <a:rPr sz="1000" b="1">
+              <a:rPr sz="1000" b="1" i="0">
                 <a:solidFill>
                   <a:srgbClr val="E7AC51"/>
                 </a:solidFill>
@@ -7892,7 +8461,7 @@
               </a:spcBef>
             </a:pPr>
             <a:r>
-              <a:rPr sz="2600" b="1">
+              <a:rPr sz="2600" b="1" i="0">
                 <a:solidFill>
                   <a:srgbClr val="ECEFF3"/>
                 </a:solidFill>
@@ -7911,7 +8480,7 @@
               </a:spcBef>
             </a:pPr>
             <a:r>
-              <a:rPr sz="1250" b="0">
+              <a:rPr sz="1250" b="0" i="0">
                 <a:solidFill>
                   <a:srgbClr val="9DA9B5"/>
                 </a:solidFill>
@@ -7930,8 +8499,8 @@
         </p:nvSpPr>
         <p:spPr>
           <a:xfrm>
-            <a:off x="4686300" y="3264408"/>
-            <a:ext cx="411480" cy="31750"/>
+            <a:off x="4686300" y="3218688"/>
+            <a:ext cx="411480" cy="32004"/>
           </a:xfrm>
           <a:prstGeom prst="rect">
             <a:avLst/>
@@ -7974,7 +8543,7 @@
         </p:nvSpPr>
         <p:spPr>
           <a:xfrm>
-            <a:off x="8138160" y="3063240"/>
+            <a:off x="8138160" y="3017520"/>
             <a:ext cx="3429000" cy="2286000"/>
           </a:xfrm>
           <a:prstGeom prst="roundRect">
@@ -8005,7 +8574,7 @@
           </a:fontRef>
         </p:style>
         <p:txBody>
-          <a:bodyPr rtlCol="0" anchor="t" wrap="square" lIns="256032" rIns="219456" tIns="384048" bIns="182880"/>
+          <a:bodyPr rtlCol="0" anchor="t" wrap="square" lIns="256032" rIns="219456" tIns="411480" bIns="182880"/>
           <a:lstStyle/>
           <a:p>
             <a:pPr algn="l">
@@ -8014,7 +8583,7 @@
               </a:lnSpc>
             </a:pPr>
             <a:r>
-              <a:rPr sz="1100" b="0">
+              <a:rPr sz="1100" b="0" i="0">
                 <a:solidFill>
                   <a:srgbClr val="403014"/>
                 </a:solidFill>
@@ -8033,7 +8602,7 @@
               </a:spcBef>
             </a:pPr>
             <a:r>
-              <a:rPr sz="1000" b="1">
+              <a:rPr sz="1000" b="1" i="0">
                 <a:solidFill>
                   <a:srgbClr val="1A1206"/>
                 </a:solidFill>
@@ -8052,7 +8621,7 @@
               </a:spcBef>
             </a:pPr>
             <a:r>
-              <a:rPr sz="2600" b="1">
+              <a:rPr sz="2600" b="1" i="0">
                 <a:solidFill>
                   <a:srgbClr val="1A1206"/>
                 </a:solidFill>
@@ -8071,7 +8640,7 @@
               </a:spcBef>
             </a:pPr>
             <a:r>
-              <a:rPr sz="1250" b="0">
+              <a:rPr sz="1250" b="0" i="0">
                 <a:solidFill>
                   <a:srgbClr val="2A1E0A"/>
                 </a:solidFill>
@@ -8090,14 +8659,14 @@
         </p:nvSpPr>
         <p:spPr>
           <a:xfrm>
-            <a:off x="8366760" y="3264408"/>
-            <a:ext cx="411480" cy="31750"/>
+            <a:off x="8366760" y="3218688"/>
+            <a:ext cx="411480" cy="32004"/>
           </a:xfrm>
           <a:prstGeom prst="rect">
             <a:avLst/>
           </a:prstGeom>
           <a:solidFill>
-            <a:srgbClr val="1A1206"/>
+            <a:srgbClr val="000000"/>
           </a:solidFill>
           <a:ln>
             <a:noFill/>
@@ -8161,7 +8730,7 @@
         <p:spPr>
           <a:xfrm>
             <a:off x="0" y="0"/>
-            <a:ext cx="12191695" cy="38100"/>
+            <a:ext cx="5486400" cy="38100"/>
           </a:xfrm>
           <a:prstGeom prst="rect">
             <a:avLst/>
@@ -8204,8 +8773,8 @@
         </p:nvSpPr>
         <p:spPr>
           <a:xfrm>
-            <a:off x="777240" y="3171444"/>
-            <a:ext cx="5989320" cy="534416"/>
+            <a:off x="914400" y="1143000"/>
+            <a:ext cx="10332720" cy="1005840"/>
           </a:xfrm>
           <a:prstGeom prst="rect">
             <a:avLst/>
@@ -8213,21 +8782,18 @@
           <a:noFill/>
         </p:spPr>
         <p:txBody>
-          <a:bodyPr wrap="square" lIns="25400" rIns="25400" tIns="12700" bIns="12700">
-            <a:noAutofit/>
+          <a:bodyPr wrap="square" anchor="t" lIns="0" rIns="0" tIns="0" bIns="0">
+            <a:spAutoFit/>
           </a:bodyPr>
           <a:lstStyle/>
           <a:p>
-            <a:pPr algn="l">
+            <a:pPr algn="ctr">
               <a:lnSpc>
-                <a:spcPct val="106000"/>
+                <a:spcPct val="100000"/>
               </a:lnSpc>
-              <a:spcAft>
-                <a:spcPts val="400"/>
-              </a:spcAft>
             </a:pPr>
             <a:r>
-              <a:rPr sz="2600" b="0">
+              <a:rPr sz="4000" b="1" i="0">
                 <a:solidFill>
                   <a:srgbClr val="ECEFF3"/>
                 </a:solidFill>
@@ -8236,7 +8802,7 @@
               <a:t>Let's step into a </a:t>
             </a:r>
             <a:r>
-              <a:rPr sz="2600" b="0">
+              <a:rPr sz="4000" b="1" i="0">
                 <a:solidFill>
                   <a:srgbClr val="E7AC51"/>
                 </a:solidFill>
@@ -8247,51 +8813,9 @@
           </a:p>
         </p:txBody>
       </p:sp>
-      <p:sp>
-        <p:nvSpPr>
-          <p:cNvPr id="4" name="TextBox 3"/>
-          <p:cNvSpPr txBox="1"/>
-          <p:nvPr/>
-        </p:nvSpPr>
-        <p:spPr>
-          <a:xfrm>
-            <a:off x="777240" y="3705860"/>
-            <a:ext cx="5989320" cy="346456"/>
-          </a:xfrm>
-          <a:prstGeom prst="rect">
-            <a:avLst/>
-          </a:prstGeom>
-          <a:noFill/>
-        </p:spPr>
-        <p:txBody>
-          <a:bodyPr wrap="square" lIns="25400" rIns="25400" tIns="12700" bIns="12700">
-            <a:noAutofit/>
-          </a:bodyPr>
-          <a:lstStyle/>
-          <a:p>
-            <a:pPr algn="l">
-              <a:lnSpc>
-                <a:spcPct val="128000"/>
-              </a:lnSpc>
-              <a:spcAft>
-                <a:spcPts val="400"/>
-              </a:spcAft>
-            </a:pPr>
-            <a:r>
-              <a:rPr sz="1400" b="0">
-                <a:solidFill>
-                  <a:srgbClr val="9DA9B5"/>
-                </a:solidFill>
-                <a:latin typeface="Arial"/>
-              </a:rPr>
-              <a:t>This field has overpromised before. Let's start there — in 1998.</a:t>
-            </a:r>
-          </a:p>
-        </p:txBody>
-      </p:sp>
       <p:pic>
         <p:nvPicPr>
-          <p:cNvPr id="5" name="Picture 4" descr="s_012a6b4f06.png"/>
+          <p:cNvPr id="4" name="Picture 3" descr="svg_9646a542a0.png"/>
           <p:cNvPicPr>
             <a:picLocks noChangeAspect="1"/>
           </p:cNvPicPr>
@@ -8305,14 +8829,53 @@
         </p:blipFill>
         <p:spPr>
           <a:xfrm>
-            <a:off x="6995160" y="2109651"/>
-            <a:ext cx="4617720" cy="2638697"/>
+            <a:off x="3794760" y="2717074"/>
+            <a:ext cx="4572000" cy="2612571"/>
           </a:xfrm>
           <a:prstGeom prst="rect">
             <a:avLst/>
           </a:prstGeom>
         </p:spPr>
       </p:pic>
+      <p:sp>
+        <p:nvSpPr>
+          <p:cNvPr id="5" name="TextBox 4"/>
+          <p:cNvSpPr txBox="1"/>
+          <p:nvPr/>
+        </p:nvSpPr>
+        <p:spPr>
+          <a:xfrm>
+            <a:off x="914400" y="5989320"/>
+            <a:ext cx="10332720" cy="457200"/>
+          </a:xfrm>
+          <a:prstGeom prst="rect">
+            <a:avLst/>
+          </a:prstGeom>
+          <a:noFill/>
+        </p:spPr>
+        <p:txBody>
+          <a:bodyPr wrap="square" anchor="t" lIns="0" rIns="0" tIns="0" bIns="0">
+            <a:spAutoFit/>
+          </a:bodyPr>
+          <a:lstStyle/>
+          <a:p>
+            <a:pPr algn="ctr">
+              <a:lnSpc>
+                <a:spcPct val="100000"/>
+              </a:lnSpc>
+            </a:pPr>
+            <a:r>
+              <a:rPr sz="1400" b="0" i="0">
+                <a:solidFill>
+                  <a:srgbClr val="9DA9B5"/>
+                </a:solidFill>
+                <a:latin typeface="Arial"/>
+              </a:rPr>
+              <a:t>This field has overpromised before. Let's start there — in 1998.</a:t>
+            </a:r>
+          </a:p>
+        </p:txBody>
+      </p:sp>
     </p:spTree>
   </p:cSld>
   <p:clrMapOvr>

</xml_diff>

<commit_message>
Transparent SVG charts by default (pptxlib.embed_svg bg=None) + gradient motif background in pptxlib.slide(); apply to all §1 SVGs (adoption curve + bar chart) and re-render hook with background
</commit_message>
<xml_diff>
--- a/keynote-iwbi-2026/pptx/sections/IWBI2026_Trivedi_00_hook.pptx
+++ b/keynote-iwbi-2026/pptx/sections/IWBI2026_Trivedi_00_hook.pptx
@@ -3871,9 +3871,33 @@
         <p:nvPr/>
       </p:nvGrpSpPr>
       <p:grpSpPr/>
-      <p:sp>
-        <p:nvSpPr>
-          <p:cNvPr id="2" name="Rectangle 1"/>
+      <p:pic>
+        <p:nvPicPr>
+          <p:cNvPr id="2" name="Picture 1" descr="bg_motif.png"/>
+          <p:cNvPicPr>
+            <a:picLocks noChangeAspect="1"/>
+          </p:cNvPicPr>
+          <p:nvPr/>
+        </p:nvPicPr>
+        <p:blipFill>
+          <a:blip r:embed="rId2"/>
+          <a:stretch>
+            <a:fillRect/>
+          </a:stretch>
+        </p:blipFill>
+        <p:spPr>
+          <a:xfrm>
+            <a:off x="0" y="0"/>
+            <a:ext cx="12191695" cy="6858000"/>
+          </a:xfrm>
+          <a:prstGeom prst="rect">
+            <a:avLst/>
+          </a:prstGeom>
+        </p:spPr>
+      </p:pic>
+      <p:sp>
+        <p:nvSpPr>
+          <p:cNvPr id="3" name="Rectangle 2"/>
           <p:cNvSpPr/>
           <p:nvPr/>
         </p:nvSpPr>
@@ -3917,7 +3941,7 @@
       </p:sp>
       <p:sp>
         <p:nvSpPr>
-          <p:cNvPr id="3" name="TextBox 2"/>
+          <p:cNvPr id="4" name="TextBox 3"/>
           <p:cNvSpPr txBox="1"/>
           <p:nvPr/>
         </p:nvSpPr>
@@ -3956,7 +3980,7 @@
       </p:sp>
       <p:sp>
         <p:nvSpPr>
-          <p:cNvPr id="4" name="TextBox 3"/>
+          <p:cNvPr id="5" name="TextBox 4"/>
           <p:cNvSpPr txBox="1"/>
           <p:nvPr/>
         </p:nvSpPr>
@@ -4011,7 +4035,7 @@
       </p:sp>
       <p:sp>
         <p:nvSpPr>
-          <p:cNvPr id="5" name="TextBox 4"/>
+          <p:cNvPr id="6" name="TextBox 5"/>
           <p:cNvSpPr txBox="1"/>
           <p:nvPr/>
         </p:nvSpPr>
@@ -4050,7 +4074,7 @@
       </p:sp>
       <p:sp>
         <p:nvSpPr>
-          <p:cNvPr id="6" name="TextBox 5"/>
+          <p:cNvPr id="7" name="TextBox 6"/>
           <p:cNvSpPr txBox="1"/>
           <p:nvPr/>
         </p:nvSpPr>
@@ -4122,9 +4146,33 @@
         <p:nvPr/>
       </p:nvGrpSpPr>
       <p:grpSpPr/>
-      <p:sp>
-        <p:nvSpPr>
-          <p:cNvPr id="2" name="Rectangle 1"/>
+      <p:pic>
+        <p:nvPicPr>
+          <p:cNvPr id="2" name="Picture 1" descr="bg_motif.png"/>
+          <p:cNvPicPr>
+            <a:picLocks noChangeAspect="1"/>
+          </p:cNvPicPr>
+          <p:nvPr/>
+        </p:nvPicPr>
+        <p:blipFill>
+          <a:blip r:embed="rId2"/>
+          <a:stretch>
+            <a:fillRect/>
+          </a:stretch>
+        </p:blipFill>
+        <p:spPr>
+          <a:xfrm>
+            <a:off x="0" y="0"/>
+            <a:ext cx="12191695" cy="6858000"/>
+          </a:xfrm>
+          <a:prstGeom prst="rect">
+            <a:avLst/>
+          </a:prstGeom>
+        </p:spPr>
+      </p:pic>
+      <p:sp>
+        <p:nvSpPr>
+          <p:cNvPr id="3" name="Rectangle 2"/>
           <p:cNvSpPr/>
           <p:nvPr/>
         </p:nvSpPr>
@@ -4168,7 +4216,7 @@
       </p:sp>
       <p:sp>
         <p:nvSpPr>
-          <p:cNvPr id="3" name="TextBox 2"/>
+          <p:cNvPr id="4" name="TextBox 3"/>
           <p:cNvSpPr txBox="1"/>
           <p:nvPr/>
         </p:nvSpPr>
@@ -4207,7 +4255,7 @@
       </p:sp>
       <p:sp>
         <p:nvSpPr>
-          <p:cNvPr id="4" name="TextBox 3"/>
+          <p:cNvPr id="5" name="TextBox 4"/>
           <p:cNvSpPr txBox="1"/>
           <p:nvPr/>
         </p:nvSpPr>
@@ -4246,7 +4294,7 @@
       </p:sp>
       <p:sp>
         <p:nvSpPr>
-          <p:cNvPr id="5" name="TextBox 4"/>
+          <p:cNvPr id="6" name="TextBox 5"/>
           <p:cNvSpPr txBox="1"/>
           <p:nvPr/>
         </p:nvSpPr>
@@ -4285,7 +4333,7 @@
       </p:sp>
       <p:sp>
         <p:nvSpPr>
-          <p:cNvPr id="6" name="Rounded Rectangle 5"/>
+          <p:cNvPr id="7" name="Rounded Rectangle 6"/>
           <p:cNvSpPr/>
           <p:nvPr/>
         </p:nvSpPr>
@@ -4344,7 +4392,7 @@
       </p:sp>
       <p:sp>
         <p:nvSpPr>
-          <p:cNvPr id="7" name="Rectangle 6"/>
+          <p:cNvPr id="8" name="Rectangle 7"/>
           <p:cNvSpPr/>
           <p:nvPr/>
         </p:nvSpPr>
@@ -4388,7 +4436,7 @@
       </p:sp>
       <p:sp>
         <p:nvSpPr>
-          <p:cNvPr id="8" name="Rounded Rectangle 7"/>
+          <p:cNvPr id="9" name="Rounded Rectangle 8"/>
           <p:cNvSpPr/>
           <p:nvPr/>
         </p:nvSpPr>
@@ -4447,7 +4495,7 @@
       </p:sp>
       <p:sp>
         <p:nvSpPr>
-          <p:cNvPr id="9" name="Rectangle 8"/>
+          <p:cNvPr id="10" name="Rectangle 9"/>
           <p:cNvSpPr/>
           <p:nvPr/>
         </p:nvSpPr>
@@ -4491,7 +4539,7 @@
       </p:sp>
       <p:sp>
         <p:nvSpPr>
-          <p:cNvPr id="10" name="TextBox 9"/>
+          <p:cNvPr id="11" name="TextBox 10"/>
           <p:cNvSpPr txBox="1"/>
           <p:nvPr/>
         </p:nvSpPr>
@@ -4530,7 +4578,7 @@
       </p:sp>
       <p:sp>
         <p:nvSpPr>
-          <p:cNvPr id="11" name="Rounded Rectangle 10"/>
+          <p:cNvPr id="12" name="Rounded Rectangle 11"/>
           <p:cNvSpPr/>
           <p:nvPr/>
         </p:nvSpPr>
@@ -4589,7 +4637,7 @@
       </p:sp>
       <p:sp>
         <p:nvSpPr>
-          <p:cNvPr id="12" name="Rectangle 11"/>
+          <p:cNvPr id="13" name="Rectangle 12"/>
           <p:cNvSpPr/>
           <p:nvPr/>
         </p:nvSpPr>
@@ -4633,7 +4681,7 @@
       </p:sp>
       <p:sp>
         <p:nvSpPr>
-          <p:cNvPr id="13" name="TextBox 12"/>
+          <p:cNvPr id="14" name="TextBox 13"/>
           <p:cNvSpPr txBox="1"/>
           <p:nvPr/>
         </p:nvSpPr>
@@ -4672,7 +4720,7 @@
       </p:sp>
       <p:sp>
         <p:nvSpPr>
-          <p:cNvPr id="14" name="Rounded Rectangle 13"/>
+          <p:cNvPr id="15" name="Rounded Rectangle 14"/>
           <p:cNvSpPr/>
           <p:nvPr/>
         </p:nvSpPr>
@@ -4731,7 +4779,7 @@
       </p:sp>
       <p:sp>
         <p:nvSpPr>
-          <p:cNvPr id="15" name="Rectangle 14"/>
+          <p:cNvPr id="16" name="Rectangle 15"/>
           <p:cNvSpPr/>
           <p:nvPr/>
         </p:nvSpPr>
@@ -4775,7 +4823,7 @@
       </p:sp>
       <p:sp>
         <p:nvSpPr>
-          <p:cNvPr id="16" name="Rounded Rectangle 15"/>
+          <p:cNvPr id="17" name="Rounded Rectangle 16"/>
           <p:cNvSpPr/>
           <p:nvPr/>
         </p:nvSpPr>
@@ -4834,7 +4882,7 @@
       </p:sp>
       <p:sp>
         <p:nvSpPr>
-          <p:cNvPr id="17" name="Rectangle 16"/>
+          <p:cNvPr id="18" name="Rectangle 17"/>
           <p:cNvSpPr/>
           <p:nvPr/>
         </p:nvSpPr>
@@ -4878,7 +4926,7 @@
       </p:sp>
       <p:sp>
         <p:nvSpPr>
-          <p:cNvPr id="18" name="Rounded Rectangle 17"/>
+          <p:cNvPr id="19" name="Rounded Rectangle 18"/>
           <p:cNvSpPr/>
           <p:nvPr/>
         </p:nvSpPr>
@@ -4937,7 +4985,7 @@
       </p:sp>
       <p:sp>
         <p:nvSpPr>
-          <p:cNvPr id="19" name="Rectangle 18"/>
+          <p:cNvPr id="20" name="Rectangle 19"/>
           <p:cNvSpPr/>
           <p:nvPr/>
         </p:nvSpPr>
@@ -4981,7 +5029,7 @@
       </p:sp>
       <p:sp>
         <p:nvSpPr>
-          <p:cNvPr id="20" name="Rounded Rectangle 19"/>
+          <p:cNvPr id="21" name="Rounded Rectangle 20"/>
           <p:cNvSpPr/>
           <p:nvPr/>
         </p:nvSpPr>
@@ -5040,7 +5088,7 @@
       </p:sp>
       <p:sp>
         <p:nvSpPr>
-          <p:cNvPr id="21" name="Rectangle 20"/>
+          <p:cNvPr id="22" name="Rectangle 21"/>
           <p:cNvSpPr/>
           <p:nvPr/>
         </p:nvSpPr>
@@ -5084,7 +5132,7 @@
       </p:sp>
       <p:sp>
         <p:nvSpPr>
-          <p:cNvPr id="22" name="Rounded Rectangle 21"/>
+          <p:cNvPr id="23" name="Rounded Rectangle 22"/>
           <p:cNvSpPr/>
           <p:nvPr/>
         </p:nvSpPr>
@@ -5143,7 +5191,7 @@
       </p:sp>
       <p:sp>
         <p:nvSpPr>
-          <p:cNvPr id="23" name="Rectangle 22"/>
+          <p:cNvPr id="24" name="Rectangle 23"/>
           <p:cNvSpPr/>
           <p:nvPr/>
         </p:nvSpPr>
@@ -5187,7 +5235,7 @@
       </p:sp>
       <p:sp>
         <p:nvSpPr>
-          <p:cNvPr id="24" name="Rounded Rectangle 23"/>
+          <p:cNvPr id="25" name="Rounded Rectangle 24"/>
           <p:cNvSpPr/>
           <p:nvPr/>
         </p:nvSpPr>
@@ -5246,7 +5294,7 @@
       </p:sp>
       <p:sp>
         <p:nvSpPr>
-          <p:cNvPr id="25" name="Rectangle 24"/>
+          <p:cNvPr id="26" name="Rectangle 25"/>
           <p:cNvSpPr/>
           <p:nvPr/>
         </p:nvSpPr>
@@ -5290,7 +5338,7 @@
       </p:sp>
       <p:sp>
         <p:nvSpPr>
-          <p:cNvPr id="26" name="Rounded Rectangle 25"/>
+          <p:cNvPr id="27" name="Rounded Rectangle 26"/>
           <p:cNvSpPr/>
           <p:nvPr/>
         </p:nvSpPr>
@@ -5349,7 +5397,7 @@
       </p:sp>
       <p:sp>
         <p:nvSpPr>
-          <p:cNvPr id="27" name="Rectangle 26"/>
+          <p:cNvPr id="28" name="Rectangle 27"/>
           <p:cNvSpPr/>
           <p:nvPr/>
         </p:nvSpPr>
@@ -5393,7 +5441,7 @@
       </p:sp>
       <p:sp>
         <p:nvSpPr>
-          <p:cNvPr id="28" name="TextBox 27"/>
+          <p:cNvPr id="29" name="TextBox 28"/>
           <p:cNvSpPr txBox="1"/>
           <p:nvPr/>
         </p:nvSpPr>
@@ -5432,7 +5480,7 @@
       </p:sp>
       <p:sp>
         <p:nvSpPr>
-          <p:cNvPr id="29" name="Rounded Rectangle 28"/>
+          <p:cNvPr id="30" name="Rounded Rectangle 29"/>
           <p:cNvSpPr/>
           <p:nvPr/>
         </p:nvSpPr>
@@ -5491,7 +5539,7 @@
       </p:sp>
       <p:sp>
         <p:nvSpPr>
-          <p:cNvPr id="30" name="Rectangle 29"/>
+          <p:cNvPr id="31" name="Rectangle 30"/>
           <p:cNvSpPr/>
           <p:nvPr/>
         </p:nvSpPr>
@@ -5535,7 +5583,7 @@
       </p:sp>
       <p:sp>
         <p:nvSpPr>
-          <p:cNvPr id="31" name="Rounded Rectangle 30"/>
+          <p:cNvPr id="32" name="Rounded Rectangle 31"/>
           <p:cNvSpPr/>
           <p:nvPr/>
         </p:nvSpPr>
@@ -5594,7 +5642,7 @@
       </p:sp>
       <p:sp>
         <p:nvSpPr>
-          <p:cNvPr id="32" name="Rectangle 31"/>
+          <p:cNvPr id="33" name="Rectangle 32"/>
           <p:cNvSpPr/>
           <p:nvPr/>
         </p:nvSpPr>
@@ -5638,7 +5686,7 @@
       </p:sp>
       <p:sp>
         <p:nvSpPr>
-          <p:cNvPr id="33" name="Rounded Rectangle 32"/>
+          <p:cNvPr id="34" name="Rounded Rectangle 33"/>
           <p:cNvSpPr/>
           <p:nvPr/>
         </p:nvSpPr>
@@ -5697,7 +5745,7 @@
       </p:sp>
       <p:sp>
         <p:nvSpPr>
-          <p:cNvPr id="34" name="Rectangle 33"/>
+          <p:cNvPr id="35" name="Rectangle 34"/>
           <p:cNvSpPr/>
           <p:nvPr/>
         </p:nvSpPr>
@@ -5741,7 +5789,7 @@
       </p:sp>
       <p:sp>
         <p:nvSpPr>
-          <p:cNvPr id="35" name="Rounded Rectangle 34"/>
+          <p:cNvPr id="36" name="Rounded Rectangle 35"/>
           <p:cNvSpPr/>
           <p:nvPr/>
         </p:nvSpPr>
@@ -5800,7 +5848,7 @@
       </p:sp>
       <p:sp>
         <p:nvSpPr>
-          <p:cNvPr id="36" name="Rectangle 35"/>
+          <p:cNvPr id="37" name="Rectangle 36"/>
           <p:cNvSpPr/>
           <p:nvPr/>
         </p:nvSpPr>
@@ -5844,7 +5892,7 @@
       </p:sp>
       <p:sp>
         <p:nvSpPr>
-          <p:cNvPr id="37" name="Rounded Rectangle 36"/>
+          <p:cNvPr id="38" name="Rounded Rectangle 37"/>
           <p:cNvSpPr/>
           <p:nvPr/>
         </p:nvSpPr>
@@ -5903,7 +5951,7 @@
       </p:sp>
       <p:sp>
         <p:nvSpPr>
-          <p:cNvPr id="38" name="Rectangle 37"/>
+          <p:cNvPr id="39" name="Rectangle 38"/>
           <p:cNvSpPr/>
           <p:nvPr/>
         </p:nvSpPr>
@@ -5947,7 +5995,7 @@
       </p:sp>
       <p:sp>
         <p:nvSpPr>
-          <p:cNvPr id="39" name="Rounded Rectangle 38"/>
+          <p:cNvPr id="40" name="Rounded Rectangle 39"/>
           <p:cNvSpPr/>
           <p:nvPr/>
         </p:nvSpPr>
@@ -6006,7 +6054,7 @@
       </p:sp>
       <p:sp>
         <p:nvSpPr>
-          <p:cNvPr id="40" name="Rectangle 39"/>
+          <p:cNvPr id="41" name="Rectangle 40"/>
           <p:cNvSpPr/>
           <p:nvPr/>
         </p:nvSpPr>
@@ -6050,7 +6098,7 @@
       </p:sp>
       <p:sp>
         <p:nvSpPr>
-          <p:cNvPr id="41" name="Rounded Rectangle 40"/>
+          <p:cNvPr id="42" name="Rounded Rectangle 41"/>
           <p:cNvSpPr/>
           <p:nvPr/>
         </p:nvSpPr>
@@ -6109,7 +6157,7 @@
       </p:sp>
       <p:sp>
         <p:nvSpPr>
-          <p:cNvPr id="42" name="Rectangle 41"/>
+          <p:cNvPr id="43" name="Rectangle 42"/>
           <p:cNvSpPr/>
           <p:nvPr/>
         </p:nvSpPr>
@@ -6153,7 +6201,7 @@
       </p:sp>
       <p:sp>
         <p:nvSpPr>
-          <p:cNvPr id="43" name="Rounded Rectangle 42"/>
+          <p:cNvPr id="44" name="Rounded Rectangle 43"/>
           <p:cNvSpPr/>
           <p:nvPr/>
         </p:nvSpPr>
@@ -6212,7 +6260,7 @@
       </p:sp>
       <p:sp>
         <p:nvSpPr>
-          <p:cNvPr id="44" name="Rectangle 43"/>
+          <p:cNvPr id="45" name="Rectangle 44"/>
           <p:cNvSpPr/>
           <p:nvPr/>
         </p:nvSpPr>
@@ -6256,7 +6304,7 @@
       </p:sp>
       <p:sp>
         <p:nvSpPr>
-          <p:cNvPr id="45" name="Rounded Rectangle 44"/>
+          <p:cNvPr id="46" name="Rounded Rectangle 45"/>
           <p:cNvSpPr/>
           <p:nvPr/>
         </p:nvSpPr>
@@ -6315,7 +6363,7 @@
       </p:sp>
       <p:sp>
         <p:nvSpPr>
-          <p:cNvPr id="46" name="Rectangle 45"/>
+          <p:cNvPr id="47" name="Rectangle 46"/>
           <p:cNvSpPr/>
           <p:nvPr/>
         </p:nvSpPr>
@@ -6359,7 +6407,7 @@
       </p:sp>
       <p:sp>
         <p:nvSpPr>
-          <p:cNvPr id="47" name="Rounded Rectangle 46"/>
+          <p:cNvPr id="48" name="Rounded Rectangle 47"/>
           <p:cNvSpPr/>
           <p:nvPr/>
         </p:nvSpPr>
@@ -6418,7 +6466,7 @@
       </p:sp>
       <p:sp>
         <p:nvSpPr>
-          <p:cNvPr id="48" name="Rectangle 47"/>
+          <p:cNvPr id="49" name="Rectangle 48"/>
           <p:cNvSpPr/>
           <p:nvPr/>
         </p:nvSpPr>
@@ -6462,7 +6510,7 @@
       </p:sp>
       <p:sp>
         <p:nvSpPr>
-          <p:cNvPr id="49" name="Rounded Rectangle 48"/>
+          <p:cNvPr id="50" name="Rounded Rectangle 49"/>
           <p:cNvSpPr/>
           <p:nvPr/>
         </p:nvSpPr>
@@ -6521,7 +6569,7 @@
       </p:sp>
       <p:sp>
         <p:nvSpPr>
-          <p:cNvPr id="50" name="Rectangle 49"/>
+          <p:cNvPr id="51" name="Rectangle 50"/>
           <p:cNvSpPr/>
           <p:nvPr/>
         </p:nvSpPr>
@@ -6565,7 +6613,7 @@
       </p:sp>
       <p:sp>
         <p:nvSpPr>
-          <p:cNvPr id="51" name="Rounded Rectangle 50"/>
+          <p:cNvPr id="52" name="Rounded Rectangle 51"/>
           <p:cNvSpPr/>
           <p:nvPr/>
         </p:nvSpPr>
@@ -6624,7 +6672,7 @@
       </p:sp>
       <p:sp>
         <p:nvSpPr>
-          <p:cNvPr id="52" name="Rectangle 51"/>
+          <p:cNvPr id="53" name="Rectangle 52"/>
           <p:cNvSpPr/>
           <p:nvPr/>
         </p:nvSpPr>
@@ -6668,7 +6716,7 @@
       </p:sp>
       <p:sp>
         <p:nvSpPr>
-          <p:cNvPr id="53" name="Rounded Rectangle 52"/>
+          <p:cNvPr id="54" name="Rounded Rectangle 53"/>
           <p:cNvSpPr/>
           <p:nvPr/>
         </p:nvSpPr>
@@ -6727,7 +6775,7 @@
       </p:sp>
       <p:sp>
         <p:nvSpPr>
-          <p:cNvPr id="54" name="Rectangle 53"/>
+          <p:cNvPr id="55" name="Rectangle 54"/>
           <p:cNvSpPr/>
           <p:nvPr/>
         </p:nvSpPr>
@@ -6771,7 +6819,7 @@
       </p:sp>
       <p:sp>
         <p:nvSpPr>
-          <p:cNvPr id="55" name="Rounded Rectangle 54"/>
+          <p:cNvPr id="56" name="Rounded Rectangle 55"/>
           <p:cNvSpPr/>
           <p:nvPr/>
         </p:nvSpPr>
@@ -6830,7 +6878,7 @@
       </p:sp>
       <p:sp>
         <p:nvSpPr>
-          <p:cNvPr id="56" name="Rectangle 55"/>
+          <p:cNvPr id="57" name="Rectangle 56"/>
           <p:cNvSpPr/>
           <p:nvPr/>
         </p:nvSpPr>
@@ -6874,7 +6922,7 @@
       </p:sp>
       <p:sp>
         <p:nvSpPr>
-          <p:cNvPr id="57" name="Rounded Rectangle 56"/>
+          <p:cNvPr id="58" name="Rounded Rectangle 57"/>
           <p:cNvSpPr/>
           <p:nvPr/>
         </p:nvSpPr>
@@ -6933,7 +6981,7 @@
       </p:sp>
       <p:sp>
         <p:nvSpPr>
-          <p:cNvPr id="58" name="Rectangle 57"/>
+          <p:cNvPr id="59" name="Rectangle 58"/>
           <p:cNvSpPr/>
           <p:nvPr/>
         </p:nvSpPr>
@@ -6977,7 +7025,7 @@
       </p:sp>
       <p:sp>
         <p:nvSpPr>
-          <p:cNvPr id="59" name="Rounded Rectangle 58"/>
+          <p:cNvPr id="60" name="Rounded Rectangle 59"/>
           <p:cNvSpPr/>
           <p:nvPr/>
         </p:nvSpPr>
@@ -7036,7 +7084,7 @@
       </p:sp>
       <p:sp>
         <p:nvSpPr>
-          <p:cNvPr id="60" name="Rectangle 59"/>
+          <p:cNvPr id="61" name="Rectangle 60"/>
           <p:cNvSpPr/>
           <p:nvPr/>
         </p:nvSpPr>
@@ -7080,7 +7128,7 @@
       </p:sp>
       <p:sp>
         <p:nvSpPr>
-          <p:cNvPr id="61" name="Rounded Rectangle 60"/>
+          <p:cNvPr id="62" name="Rounded Rectangle 61"/>
           <p:cNvSpPr/>
           <p:nvPr/>
         </p:nvSpPr>
@@ -7139,7 +7187,7 @@
       </p:sp>
       <p:sp>
         <p:nvSpPr>
-          <p:cNvPr id="62" name="Rectangle 61"/>
+          <p:cNvPr id="63" name="Rectangle 62"/>
           <p:cNvSpPr/>
           <p:nvPr/>
         </p:nvSpPr>
@@ -7183,7 +7231,7 @@
       </p:sp>
       <p:sp>
         <p:nvSpPr>
-          <p:cNvPr id="63" name="Rounded Rectangle 62"/>
+          <p:cNvPr id="64" name="Rounded Rectangle 63"/>
           <p:cNvSpPr/>
           <p:nvPr/>
         </p:nvSpPr>
@@ -7242,7 +7290,7 @@
       </p:sp>
       <p:sp>
         <p:nvSpPr>
-          <p:cNvPr id="64" name="Rectangle 63"/>
+          <p:cNvPr id="65" name="Rectangle 64"/>
           <p:cNvSpPr/>
           <p:nvPr/>
         </p:nvSpPr>
@@ -7310,9 +7358,33 @@
         <p:nvPr/>
       </p:nvGrpSpPr>
       <p:grpSpPr/>
-      <p:sp>
-        <p:nvSpPr>
-          <p:cNvPr id="2" name="Rectangle 1"/>
+      <p:pic>
+        <p:nvPicPr>
+          <p:cNvPr id="2" name="Picture 1" descr="bg_motif.png"/>
+          <p:cNvPicPr>
+            <a:picLocks noChangeAspect="1"/>
+          </p:cNvPicPr>
+          <p:nvPr/>
+        </p:nvPicPr>
+        <p:blipFill>
+          <a:blip r:embed="rId2"/>
+          <a:stretch>
+            <a:fillRect/>
+          </a:stretch>
+        </p:blipFill>
+        <p:spPr>
+          <a:xfrm>
+            <a:off x="0" y="0"/>
+            <a:ext cx="12191695" cy="6858000"/>
+          </a:xfrm>
+          <a:prstGeom prst="rect">
+            <a:avLst/>
+          </a:prstGeom>
+        </p:spPr>
+      </p:pic>
+      <p:sp>
+        <p:nvSpPr>
+          <p:cNvPr id="3" name="Rectangle 2"/>
           <p:cNvSpPr/>
           <p:nvPr/>
         </p:nvSpPr>
@@ -7356,7 +7428,7 @@
       </p:sp>
       <p:sp>
         <p:nvSpPr>
-          <p:cNvPr id="3" name="Rounded Rectangle 2"/>
+          <p:cNvPr id="4" name="Rounded Rectangle 3"/>
           <p:cNvSpPr/>
           <p:nvPr/>
         </p:nvSpPr>
@@ -7402,7 +7474,7 @@
       </p:sp>
       <p:sp>
         <p:nvSpPr>
-          <p:cNvPr id="4" name="TextBox 3"/>
+          <p:cNvPr id="5" name="TextBox 4"/>
           <p:cNvSpPr txBox="1"/>
           <p:nvPr/>
         </p:nvSpPr>
@@ -7441,7 +7513,7 @@
       </p:sp>
       <p:sp>
         <p:nvSpPr>
-          <p:cNvPr id="5" name="TextBox 4"/>
+          <p:cNvPr id="6" name="TextBox 5"/>
           <p:cNvSpPr txBox="1"/>
           <p:nvPr/>
         </p:nvSpPr>
@@ -7480,7 +7552,7 @@
       </p:sp>
       <p:sp>
         <p:nvSpPr>
-          <p:cNvPr id="6" name="Rectangle 5"/>
+          <p:cNvPr id="7" name="Rectangle 6"/>
           <p:cNvSpPr/>
           <p:nvPr/>
         </p:nvSpPr>
@@ -7524,7 +7596,7 @@
       </p:sp>
       <p:sp>
         <p:nvSpPr>
-          <p:cNvPr id="7" name="Rectangle 6"/>
+          <p:cNvPr id="8" name="Rectangle 7"/>
           <p:cNvSpPr/>
           <p:nvPr/>
         </p:nvSpPr>
@@ -7568,7 +7640,7 @@
       </p:sp>
       <p:sp>
         <p:nvSpPr>
-          <p:cNvPr id="8" name="TextBox 7"/>
+          <p:cNvPr id="9" name="TextBox 8"/>
           <p:cNvSpPr txBox="1"/>
           <p:nvPr/>
         </p:nvSpPr>
@@ -7607,7 +7679,7 @@
       </p:sp>
       <p:sp>
         <p:nvSpPr>
-          <p:cNvPr id="9" name="TextBox 8"/>
+          <p:cNvPr id="10" name="TextBox 9"/>
           <p:cNvSpPr txBox="1"/>
           <p:nvPr/>
         </p:nvSpPr>
@@ -7670,9 +7742,33 @@
         <p:nvPr/>
       </p:nvGrpSpPr>
       <p:grpSpPr/>
-      <p:sp>
-        <p:nvSpPr>
-          <p:cNvPr id="2" name="Rectangle 1"/>
+      <p:pic>
+        <p:nvPicPr>
+          <p:cNvPr id="2" name="Picture 1" descr="bg_motif.png"/>
+          <p:cNvPicPr>
+            <a:picLocks noChangeAspect="1"/>
+          </p:cNvPicPr>
+          <p:nvPr/>
+        </p:nvPicPr>
+        <p:blipFill>
+          <a:blip r:embed="rId2"/>
+          <a:stretch>
+            <a:fillRect/>
+          </a:stretch>
+        </p:blipFill>
+        <p:spPr>
+          <a:xfrm>
+            <a:off x="0" y="0"/>
+            <a:ext cx="12191695" cy="6858000"/>
+          </a:xfrm>
+          <a:prstGeom prst="rect">
+            <a:avLst/>
+          </a:prstGeom>
+        </p:spPr>
+      </p:pic>
+      <p:sp>
+        <p:nvSpPr>
+          <p:cNvPr id="3" name="Rectangle 2"/>
           <p:cNvSpPr/>
           <p:nvPr/>
         </p:nvSpPr>
@@ -7716,7 +7812,7 @@
       </p:sp>
       <p:sp>
         <p:nvSpPr>
-          <p:cNvPr id="3" name="Rounded Rectangle 2"/>
+          <p:cNvPr id="4" name="Rounded Rectangle 3"/>
           <p:cNvSpPr/>
           <p:nvPr/>
         </p:nvSpPr>
@@ -7762,7 +7858,7 @@
       </p:sp>
       <p:sp>
         <p:nvSpPr>
-          <p:cNvPr id="4" name="TextBox 3"/>
+          <p:cNvPr id="5" name="TextBox 4"/>
           <p:cNvSpPr txBox="1"/>
           <p:nvPr/>
         </p:nvSpPr>
@@ -7801,7 +7897,7 @@
       </p:sp>
       <p:sp>
         <p:nvSpPr>
-          <p:cNvPr id="5" name="TextBox 4"/>
+          <p:cNvPr id="6" name="TextBox 5"/>
           <p:cNvSpPr txBox="1"/>
           <p:nvPr/>
         </p:nvSpPr>
@@ -7840,7 +7936,7 @@
       </p:sp>
       <p:sp>
         <p:nvSpPr>
-          <p:cNvPr id="6" name="Rectangle 5"/>
+          <p:cNvPr id="7" name="Rectangle 6"/>
           <p:cNvSpPr/>
           <p:nvPr/>
         </p:nvSpPr>
@@ -7884,7 +7980,7 @@
       </p:sp>
       <p:sp>
         <p:nvSpPr>
-          <p:cNvPr id="7" name="Rectangle 6"/>
+          <p:cNvPr id="8" name="Rectangle 7"/>
           <p:cNvSpPr/>
           <p:nvPr/>
         </p:nvSpPr>
@@ -7928,7 +8024,7 @@
       </p:sp>
       <p:sp>
         <p:nvSpPr>
-          <p:cNvPr id="8" name="TextBox 7"/>
+          <p:cNvPr id="9" name="TextBox 8"/>
           <p:cNvSpPr txBox="1"/>
           <p:nvPr/>
         </p:nvSpPr>
@@ -7967,7 +8063,7 @@
       </p:sp>
       <p:sp>
         <p:nvSpPr>
-          <p:cNvPr id="9" name="TextBox 8"/>
+          <p:cNvPr id="10" name="TextBox 9"/>
           <p:cNvSpPr txBox="1"/>
           <p:nvPr/>
         </p:nvSpPr>
@@ -8015,7 +8111,7 @@
       </p:sp>
       <p:sp>
         <p:nvSpPr>
-          <p:cNvPr id="10" name="TextBox 9"/>
+          <p:cNvPr id="11" name="TextBox 10"/>
           <p:cNvSpPr txBox="1"/>
           <p:nvPr/>
         </p:nvSpPr>
@@ -8123,9 +8219,33 @@
         <p:nvPr/>
       </p:nvGrpSpPr>
       <p:grpSpPr/>
-      <p:sp>
-        <p:nvSpPr>
-          <p:cNvPr id="2" name="Rectangle 1"/>
+      <p:pic>
+        <p:nvPicPr>
+          <p:cNvPr id="2" name="Picture 1" descr="bg_motif.png"/>
+          <p:cNvPicPr>
+            <a:picLocks noChangeAspect="1"/>
+          </p:cNvPicPr>
+          <p:nvPr/>
+        </p:nvPicPr>
+        <p:blipFill>
+          <a:blip r:embed="rId2"/>
+          <a:stretch>
+            <a:fillRect/>
+          </a:stretch>
+        </p:blipFill>
+        <p:spPr>
+          <a:xfrm>
+            <a:off x="0" y="0"/>
+            <a:ext cx="12191695" cy="6858000"/>
+          </a:xfrm>
+          <a:prstGeom prst="rect">
+            <a:avLst/>
+          </a:prstGeom>
+        </p:spPr>
+      </p:pic>
+      <p:sp>
+        <p:nvSpPr>
+          <p:cNvPr id="3" name="Rectangle 2"/>
           <p:cNvSpPr/>
           <p:nvPr/>
         </p:nvSpPr>
@@ -8169,7 +8289,7 @@
       </p:sp>
       <p:sp>
         <p:nvSpPr>
-          <p:cNvPr id="3" name="TextBox 2"/>
+          <p:cNvPr id="4" name="TextBox 3"/>
           <p:cNvSpPr txBox="1"/>
           <p:nvPr/>
         </p:nvSpPr>
@@ -8217,7 +8337,7 @@
       </p:sp>
       <p:sp>
         <p:nvSpPr>
-          <p:cNvPr id="4" name="Rounded Rectangle 3"/>
+          <p:cNvPr id="5" name="Rounded Rectangle 4"/>
           <p:cNvSpPr/>
           <p:nvPr/>
         </p:nvSpPr>
@@ -8333,7 +8453,7 @@
       </p:sp>
       <p:sp>
         <p:nvSpPr>
-          <p:cNvPr id="5" name="Rectangle 4"/>
+          <p:cNvPr id="6" name="Rectangle 5"/>
           <p:cNvSpPr/>
           <p:nvPr/>
         </p:nvSpPr>
@@ -8377,7 +8497,7 @@
       </p:sp>
       <p:sp>
         <p:nvSpPr>
-          <p:cNvPr id="6" name="Rounded Rectangle 5"/>
+          <p:cNvPr id="7" name="Rounded Rectangle 6"/>
           <p:cNvSpPr/>
           <p:nvPr/>
         </p:nvSpPr>
@@ -8493,7 +8613,7 @@
       </p:sp>
       <p:sp>
         <p:nvSpPr>
-          <p:cNvPr id="7" name="Rectangle 6"/>
+          <p:cNvPr id="8" name="Rectangle 7"/>
           <p:cNvSpPr/>
           <p:nvPr/>
         </p:nvSpPr>
@@ -8537,7 +8657,7 @@
       </p:sp>
       <p:sp>
         <p:nvSpPr>
-          <p:cNvPr id="8" name="Rounded Rectangle 7"/>
+          <p:cNvPr id="9" name="Rounded Rectangle 8"/>
           <p:cNvSpPr/>
           <p:nvPr/>
         </p:nvSpPr>
@@ -8653,7 +8773,7 @@
       </p:sp>
       <p:sp>
         <p:nvSpPr>
-          <p:cNvPr id="9" name="Rectangle 8"/>
+          <p:cNvPr id="10" name="Rectangle 9"/>
           <p:cNvSpPr/>
           <p:nvPr/>
         </p:nvSpPr>
@@ -8721,9 +8841,33 @@
         <p:nvPr/>
       </p:nvGrpSpPr>
       <p:grpSpPr/>
-      <p:sp>
-        <p:nvSpPr>
-          <p:cNvPr id="2" name="Rectangle 1"/>
+      <p:pic>
+        <p:nvPicPr>
+          <p:cNvPr id="2" name="Picture 1" descr="bg_motif.png"/>
+          <p:cNvPicPr>
+            <a:picLocks noChangeAspect="1"/>
+          </p:cNvPicPr>
+          <p:nvPr/>
+        </p:nvPicPr>
+        <p:blipFill>
+          <a:blip r:embed="rId2"/>
+          <a:stretch>
+            <a:fillRect/>
+          </a:stretch>
+        </p:blipFill>
+        <p:spPr>
+          <a:xfrm>
+            <a:off x="0" y="0"/>
+            <a:ext cx="12191695" cy="6858000"/>
+          </a:xfrm>
+          <a:prstGeom prst="rect">
+            <a:avLst/>
+          </a:prstGeom>
+        </p:spPr>
+      </p:pic>
+      <p:sp>
+        <p:nvSpPr>
+          <p:cNvPr id="3" name="Rectangle 2"/>
           <p:cNvSpPr/>
           <p:nvPr/>
         </p:nvSpPr>
@@ -8767,7 +8911,7 @@
       </p:sp>
       <p:sp>
         <p:nvSpPr>
-          <p:cNvPr id="3" name="TextBox 2"/>
+          <p:cNvPr id="4" name="TextBox 3"/>
           <p:cNvSpPr txBox="1"/>
           <p:nvPr/>
         </p:nvSpPr>
@@ -8815,14 +8959,14 @@
       </p:sp>
       <p:pic>
         <p:nvPicPr>
-          <p:cNvPr id="4" name="Picture 3" descr="svg_9646a542a0.png"/>
+          <p:cNvPr id="5" name="Picture 4" descr="svg_9646a542a0.png"/>
           <p:cNvPicPr>
             <a:picLocks noChangeAspect="1"/>
           </p:cNvPicPr>
           <p:nvPr/>
         </p:nvPicPr>
         <p:blipFill>
-          <a:blip r:embed="rId3"/>
+          <a:blip r:embed="rId4"/>
           <a:stretch>
             <a:fillRect/>
           </a:stretch>
@@ -8839,7 +8983,7 @@
       </p:pic>
       <p:sp>
         <p:nvSpPr>
-          <p:cNvPr id="5" name="TextBox 4"/>
+          <p:cNvPr id="6" name="TextBox 5"/>
           <p:cNvSpPr txBox="1"/>
           <p:nvPr/>
         </p:nvSpPr>

</xml_diff>